<commit_message>
Pull Drive-newer deck 0_genAI_in_Python.pptx (edited on Drive 2026-09-01 evening)
Co-Authored-By: Claude Fable 5.1 <noreply@anthropic.com>
Claude-Session: https://claude.ai/code/session_01XuW7eMFtbgnWUtwBFBtuVN
</commit_message>
<xml_diff>
--- a/0_genAI_in_Python.pptx
+++ b/0_genAI_in_Python.pptx
@@ -70,7 +70,7 @@
         <a:srgbClr val="000000"/>
       </a:buClr>
       <a:buFont typeface="Arial"/>
-      <a:defRPr b="0" i="0" sz="1400" u="none" cap="none" strike="noStrike">
+      <a:defRPr b="0" i="0" spc="0" sz="1400" u="none" cap="none" strike="noStrike">
         <a:solidFill>
           <a:srgbClr val="000000"/>
         </a:solidFill>
@@ -94,7 +94,7 @@
         <a:srgbClr val="000000"/>
       </a:buClr>
       <a:buFont typeface="Arial"/>
-      <a:defRPr b="0" i="0" sz="1400" u="none" cap="none" strike="noStrike">
+      <a:defRPr b="0" i="0" spc="0" sz="1400" u="none" cap="none" strike="noStrike">
         <a:solidFill>
           <a:srgbClr val="000000"/>
         </a:solidFill>
@@ -118,7 +118,7 @@
         <a:srgbClr val="000000"/>
       </a:buClr>
       <a:buFont typeface="Arial"/>
-      <a:defRPr b="0" i="0" sz="1400" u="none" cap="none" strike="noStrike">
+      <a:defRPr b="0" i="0" spc="0" sz="1400" u="none" cap="none" strike="noStrike">
         <a:solidFill>
           <a:srgbClr val="000000"/>
         </a:solidFill>
@@ -142,7 +142,7 @@
         <a:srgbClr val="000000"/>
       </a:buClr>
       <a:buFont typeface="Arial"/>
-      <a:defRPr b="0" i="0" sz="1400" u="none" cap="none" strike="noStrike">
+      <a:defRPr b="0" i="0" spc="0" sz="1400" u="none" cap="none" strike="noStrike">
         <a:solidFill>
           <a:srgbClr val="000000"/>
         </a:solidFill>
@@ -166,7 +166,7 @@
         <a:srgbClr val="000000"/>
       </a:buClr>
       <a:buFont typeface="Arial"/>
-      <a:defRPr b="0" i="0" sz="1400" u="none" cap="none" strike="noStrike">
+      <a:defRPr b="0" i="0" spc="0" sz="1400" u="none" cap="none" strike="noStrike">
         <a:solidFill>
           <a:srgbClr val="000000"/>
         </a:solidFill>
@@ -190,7 +190,7 @@
         <a:srgbClr val="000000"/>
       </a:buClr>
       <a:buFont typeface="Arial"/>
-      <a:defRPr b="0" i="0" sz="1400" u="none" cap="none" strike="noStrike">
+      <a:defRPr b="0" i="0" spc="0" sz="1400" u="none" cap="none" strike="noStrike">
         <a:solidFill>
           <a:srgbClr val="000000"/>
         </a:solidFill>
@@ -214,7 +214,7 @@
         <a:srgbClr val="000000"/>
       </a:buClr>
       <a:buFont typeface="Arial"/>
-      <a:defRPr b="0" i="0" sz="1400" u="none" cap="none" strike="noStrike">
+      <a:defRPr b="0" i="0" spc="0" sz="1400" u="none" cap="none" strike="noStrike">
         <a:solidFill>
           <a:srgbClr val="000000"/>
         </a:solidFill>
@@ -238,7 +238,7 @@
         <a:srgbClr val="000000"/>
       </a:buClr>
       <a:buFont typeface="Arial"/>
-      <a:defRPr b="0" i="0" sz="1400" u="none" cap="none" strike="noStrike">
+      <a:defRPr b="0" i="0" spc="0" sz="1400" u="none" cap="none" strike="noStrike">
         <a:solidFill>
           <a:srgbClr val="000000"/>
         </a:solidFill>
@@ -262,7 +262,7 @@
         <a:srgbClr val="000000"/>
       </a:buClr>
       <a:buFont typeface="Arial"/>
-      <a:defRPr b="0" i="0" sz="1400" u="none" cap="none" strike="noStrike">
+      <a:defRPr b="0" i="0" spc="0" sz="1400" u="none" cap="none" strike="noStrike">
         <a:solidFill>
           <a:srgbClr val="000000"/>
         </a:solidFill>
@@ -650,7 +650,7 @@
         <a:srgbClr val="000000"/>
       </a:buClr>
       <a:buFont typeface="Arial"/>
-      <a:defRPr b="0" i="0" sz="1400" u="none" cap="none" strike="noStrike">
+      <a:defRPr b="0" i="0" spc="0" sz="1400" u="none" cap="none" strike="noStrike">
         <a:solidFill>
           <a:srgbClr val="000000"/>
         </a:solidFill>
@@ -674,7 +674,7 @@
         <a:srgbClr val="000000"/>
       </a:buClr>
       <a:buFont typeface="Arial"/>
-      <a:defRPr b="0" i="0" sz="1400" u="none" cap="none" strike="noStrike">
+      <a:defRPr b="0" i="0" spc="0" sz="1400" u="none" cap="none" strike="noStrike">
         <a:solidFill>
           <a:srgbClr val="000000"/>
         </a:solidFill>
@@ -698,7 +698,7 @@
         <a:srgbClr val="000000"/>
       </a:buClr>
       <a:buFont typeface="Arial"/>
-      <a:defRPr b="0" i="0" sz="1400" u="none" cap="none" strike="noStrike">
+      <a:defRPr b="0" i="0" spc="0" sz="1400" u="none" cap="none" strike="noStrike">
         <a:solidFill>
           <a:srgbClr val="000000"/>
         </a:solidFill>
@@ -722,7 +722,7 @@
         <a:srgbClr val="000000"/>
       </a:buClr>
       <a:buFont typeface="Arial"/>
-      <a:defRPr b="0" i="0" sz="1400" u="none" cap="none" strike="noStrike">
+      <a:defRPr b="0" i="0" spc="0" sz="1400" u="none" cap="none" strike="noStrike">
         <a:solidFill>
           <a:srgbClr val="000000"/>
         </a:solidFill>
@@ -746,7 +746,7 @@
         <a:srgbClr val="000000"/>
       </a:buClr>
       <a:buFont typeface="Arial"/>
-      <a:defRPr b="0" i="0" sz="1400" u="none" cap="none" strike="noStrike">
+      <a:defRPr b="0" i="0" spc="0" sz="1400" u="none" cap="none" strike="noStrike">
         <a:solidFill>
           <a:srgbClr val="000000"/>
         </a:solidFill>
@@ -770,7 +770,7 @@
         <a:srgbClr val="000000"/>
       </a:buClr>
       <a:buFont typeface="Arial"/>
-      <a:defRPr b="0" i="0" sz="1400" u="none" cap="none" strike="noStrike">
+      <a:defRPr b="0" i="0" spc="0" sz="1400" u="none" cap="none" strike="noStrike">
         <a:solidFill>
           <a:srgbClr val="000000"/>
         </a:solidFill>
@@ -794,7 +794,7 @@
         <a:srgbClr val="000000"/>
       </a:buClr>
       <a:buFont typeface="Arial"/>
-      <a:defRPr b="0" i="0" sz="1400" u="none" cap="none" strike="noStrike">
+      <a:defRPr b="0" i="0" spc="0" sz="1400" u="none" cap="none" strike="noStrike">
         <a:solidFill>
           <a:srgbClr val="000000"/>
         </a:solidFill>
@@ -818,7 +818,7 @@
         <a:srgbClr val="000000"/>
       </a:buClr>
       <a:buFont typeface="Arial"/>
-      <a:defRPr b="0" i="0" sz="1400" u="none" cap="none" strike="noStrike">
+      <a:defRPr b="0" i="0" spc="0" sz="1400" u="none" cap="none" strike="noStrike">
         <a:solidFill>
           <a:srgbClr val="000000"/>
         </a:solidFill>
@@ -842,7 +842,7 @@
         <a:srgbClr val="000000"/>
       </a:buClr>
       <a:buFont typeface="Arial"/>
-      <a:defRPr b="0" i="0" sz="1400" u="none" cap="none" strike="noStrike">
+      <a:defRPr b="0" i="0" spc="0" sz="1400" u="none" cap="none" strike="noStrike">
         <a:solidFill>
           <a:srgbClr val="000000"/>
         </a:solidFill>
@@ -24245,7 +24245,7 @@
           <a:srgbClr val="000000"/>
         </a:buClr>
         <a:buFont typeface="Arial"/>
-        <a:defRPr b="0" i="0" sz="1400" u="none" cap="none" strike="noStrike">
+        <a:defRPr b="0" i="0" spc="0" sz="1400" u="none" cap="none" strike="noStrike">
           <a:solidFill>
             <a:srgbClr val="000000"/>
           </a:solidFill>
@@ -24269,7 +24269,7 @@
           <a:srgbClr val="000000"/>
         </a:buClr>
         <a:buFont typeface="Arial"/>
-        <a:defRPr b="0" i="0" sz="1400" u="none" cap="none" strike="noStrike">
+        <a:defRPr b="0" i="0" spc="0" sz="1400" u="none" cap="none" strike="noStrike">
           <a:solidFill>
             <a:srgbClr val="000000"/>
           </a:solidFill>
@@ -24293,7 +24293,7 @@
           <a:srgbClr val="000000"/>
         </a:buClr>
         <a:buFont typeface="Arial"/>
-        <a:defRPr b="0" i="0" sz="1400" u="none" cap="none" strike="noStrike">
+        <a:defRPr b="0" i="0" spc="0" sz="1400" u="none" cap="none" strike="noStrike">
           <a:solidFill>
             <a:srgbClr val="000000"/>
           </a:solidFill>
@@ -24317,7 +24317,7 @@
           <a:srgbClr val="000000"/>
         </a:buClr>
         <a:buFont typeface="Arial"/>
-        <a:defRPr b="0" i="0" sz="1400" u="none" cap="none" strike="noStrike">
+        <a:defRPr b="0" i="0" spc="0" sz="1400" u="none" cap="none" strike="noStrike">
           <a:solidFill>
             <a:srgbClr val="000000"/>
           </a:solidFill>
@@ -24341,7 +24341,7 @@
           <a:srgbClr val="000000"/>
         </a:buClr>
         <a:buFont typeface="Arial"/>
-        <a:defRPr b="0" i="0" sz="1400" u="none" cap="none" strike="noStrike">
+        <a:defRPr b="0" i="0" spc="0" sz="1400" u="none" cap="none" strike="noStrike">
           <a:solidFill>
             <a:srgbClr val="000000"/>
           </a:solidFill>
@@ -24365,7 +24365,7 @@
           <a:srgbClr val="000000"/>
         </a:buClr>
         <a:buFont typeface="Arial"/>
-        <a:defRPr b="0" i="0" sz="1400" u="none" cap="none" strike="noStrike">
+        <a:defRPr b="0" i="0" spc="0" sz="1400" u="none" cap="none" strike="noStrike">
           <a:solidFill>
             <a:srgbClr val="000000"/>
           </a:solidFill>
@@ -24389,7 +24389,7 @@
           <a:srgbClr val="000000"/>
         </a:buClr>
         <a:buFont typeface="Arial"/>
-        <a:defRPr b="0" i="0" sz="1400" u="none" cap="none" strike="noStrike">
+        <a:defRPr b="0" i="0" spc="0" sz="1400" u="none" cap="none" strike="noStrike">
           <a:solidFill>
             <a:srgbClr val="000000"/>
           </a:solidFill>
@@ -24413,7 +24413,7 @@
           <a:srgbClr val="000000"/>
         </a:buClr>
         <a:buFont typeface="Arial"/>
-        <a:defRPr b="0" i="0" sz="1400" u="none" cap="none" strike="noStrike">
+        <a:defRPr b="0" i="0" spc="0" sz="1400" u="none" cap="none" strike="noStrike">
           <a:solidFill>
             <a:srgbClr val="000000"/>
           </a:solidFill>
@@ -24437,7 +24437,7 @@
           <a:srgbClr val="000000"/>
         </a:buClr>
         <a:buFont typeface="Arial"/>
-        <a:defRPr b="0" i="0" sz="1400" u="none" cap="none" strike="noStrike">
+        <a:defRPr b="0" i="0" spc="0" sz="1400" u="none" cap="none" strike="noStrike">
           <a:solidFill>
             <a:srgbClr val="000000"/>
           </a:solidFill>
@@ -24474,7 +24474,7 @@
           <a:srgbClr val="000000"/>
         </a:buClr>
         <a:buFont typeface="Arial"/>
-        <a:defRPr b="0" i="0" sz="1400" u="none" cap="none" strike="noStrike">
+        <a:defRPr b="0" i="0" spc="0" sz="1400" u="none" cap="none" strike="noStrike">
           <a:solidFill>
             <a:srgbClr val="000000"/>
           </a:solidFill>
@@ -24498,7 +24498,7 @@
           <a:srgbClr val="000000"/>
         </a:buClr>
         <a:buFont typeface="Arial"/>
-        <a:defRPr b="0" i="0" sz="1400" u="none" cap="none" strike="noStrike">
+        <a:defRPr b="0" i="0" spc="0" sz="1400" u="none" cap="none" strike="noStrike">
           <a:solidFill>
             <a:srgbClr val="000000"/>
           </a:solidFill>
@@ -24522,7 +24522,7 @@
           <a:srgbClr val="000000"/>
         </a:buClr>
         <a:buFont typeface="Arial"/>
-        <a:defRPr b="0" i="0" sz="1400" u="none" cap="none" strike="noStrike">
+        <a:defRPr b="0" i="0" spc="0" sz="1400" u="none" cap="none" strike="noStrike">
           <a:solidFill>
             <a:srgbClr val="000000"/>
           </a:solidFill>
@@ -24546,7 +24546,7 @@
           <a:srgbClr val="000000"/>
         </a:buClr>
         <a:buFont typeface="Arial"/>
-        <a:defRPr b="0" i="0" sz="1400" u="none" cap="none" strike="noStrike">
+        <a:defRPr b="0" i="0" spc="0" sz="1400" u="none" cap="none" strike="noStrike">
           <a:solidFill>
             <a:srgbClr val="000000"/>
           </a:solidFill>
@@ -24570,7 +24570,7 @@
           <a:srgbClr val="000000"/>
         </a:buClr>
         <a:buFont typeface="Arial"/>
-        <a:defRPr b="0" i="0" sz="1400" u="none" cap="none" strike="noStrike">
+        <a:defRPr b="0" i="0" spc="0" sz="1400" u="none" cap="none" strike="noStrike">
           <a:solidFill>
             <a:srgbClr val="000000"/>
           </a:solidFill>
@@ -24594,7 +24594,7 @@
           <a:srgbClr val="000000"/>
         </a:buClr>
         <a:buFont typeface="Arial"/>
-        <a:defRPr b="0" i="0" sz="1400" u="none" cap="none" strike="noStrike">
+        <a:defRPr b="0" i="0" spc="0" sz="1400" u="none" cap="none" strike="noStrike">
           <a:solidFill>
             <a:srgbClr val="000000"/>
           </a:solidFill>
@@ -24618,7 +24618,7 @@
           <a:srgbClr val="000000"/>
         </a:buClr>
         <a:buFont typeface="Arial"/>
-        <a:defRPr b="0" i="0" sz="1400" u="none" cap="none" strike="noStrike">
+        <a:defRPr b="0" i="0" spc="0" sz="1400" u="none" cap="none" strike="noStrike">
           <a:solidFill>
             <a:srgbClr val="000000"/>
           </a:solidFill>
@@ -24642,7 +24642,7 @@
           <a:srgbClr val="000000"/>
         </a:buClr>
         <a:buFont typeface="Arial"/>
-        <a:defRPr b="0" i="0" sz="1400" u="none" cap="none" strike="noStrike">
+        <a:defRPr b="0" i="0" spc="0" sz="1400" u="none" cap="none" strike="noStrike">
           <a:solidFill>
             <a:srgbClr val="000000"/>
           </a:solidFill>
@@ -24666,7 +24666,7 @@
           <a:srgbClr val="000000"/>
         </a:buClr>
         <a:buFont typeface="Arial"/>
-        <a:defRPr b="0" i="0" sz="1400" u="none" cap="none" strike="noStrike">
+        <a:defRPr b="0" i="0" spc="0" sz="1400" u="none" cap="none" strike="noStrike">
           <a:solidFill>
             <a:srgbClr val="000000"/>
           </a:solidFill>
@@ -24703,7 +24703,7 @@
           <a:srgbClr val="000000"/>
         </a:buClr>
         <a:buFont typeface="Arial"/>
-        <a:defRPr b="0" i="0" sz="1400" u="none" cap="none" strike="noStrike">
+        <a:defRPr b="0" i="0" spc="0" sz="1400" u="none" cap="none" strike="noStrike">
           <a:solidFill>
             <a:srgbClr val="000000"/>
           </a:solidFill>
@@ -24727,7 +24727,7 @@
           <a:srgbClr val="000000"/>
         </a:buClr>
         <a:buFont typeface="Arial"/>
-        <a:defRPr b="0" i="0" sz="1400" u="none" cap="none" strike="noStrike">
+        <a:defRPr b="0" i="0" spc="0" sz="1400" u="none" cap="none" strike="noStrike">
           <a:solidFill>
             <a:srgbClr val="000000"/>
           </a:solidFill>
@@ -24751,7 +24751,7 @@
           <a:srgbClr val="000000"/>
         </a:buClr>
         <a:buFont typeface="Arial"/>
-        <a:defRPr b="0" i="0" sz="1400" u="none" cap="none" strike="noStrike">
+        <a:defRPr b="0" i="0" spc="0" sz="1400" u="none" cap="none" strike="noStrike">
           <a:solidFill>
             <a:srgbClr val="000000"/>
           </a:solidFill>
@@ -24775,7 +24775,7 @@
           <a:srgbClr val="000000"/>
         </a:buClr>
         <a:buFont typeface="Arial"/>
-        <a:defRPr b="0" i="0" sz="1400" u="none" cap="none" strike="noStrike">
+        <a:defRPr b="0" i="0" spc="0" sz="1400" u="none" cap="none" strike="noStrike">
           <a:solidFill>
             <a:srgbClr val="000000"/>
           </a:solidFill>
@@ -24799,7 +24799,7 @@
           <a:srgbClr val="000000"/>
         </a:buClr>
         <a:buFont typeface="Arial"/>
-        <a:defRPr b="0" i="0" sz="1400" u="none" cap="none" strike="noStrike">
+        <a:defRPr b="0" i="0" spc="0" sz="1400" u="none" cap="none" strike="noStrike">
           <a:solidFill>
             <a:srgbClr val="000000"/>
           </a:solidFill>
@@ -24823,7 +24823,7 @@
           <a:srgbClr val="000000"/>
         </a:buClr>
         <a:buFont typeface="Arial"/>
-        <a:defRPr b="0" i="0" sz="1400" u="none" cap="none" strike="noStrike">
+        <a:defRPr b="0" i="0" spc="0" sz="1400" u="none" cap="none" strike="noStrike">
           <a:solidFill>
             <a:srgbClr val="000000"/>
           </a:solidFill>
@@ -24847,7 +24847,7 @@
           <a:srgbClr val="000000"/>
         </a:buClr>
         <a:buFont typeface="Arial"/>
-        <a:defRPr b="0" i="0" sz="1400" u="none" cap="none" strike="noStrike">
+        <a:defRPr b="0" i="0" spc="0" sz="1400" u="none" cap="none" strike="noStrike">
           <a:solidFill>
             <a:srgbClr val="000000"/>
           </a:solidFill>
@@ -24871,7 +24871,7 @@
           <a:srgbClr val="000000"/>
         </a:buClr>
         <a:buFont typeface="Arial"/>
-        <a:defRPr b="0" i="0" sz="1400" u="none" cap="none" strike="noStrike">
+        <a:defRPr b="0" i="0" spc="0" sz="1400" u="none" cap="none" strike="noStrike">
           <a:solidFill>
             <a:srgbClr val="000000"/>
           </a:solidFill>
@@ -24895,7 +24895,7 @@
           <a:srgbClr val="000000"/>
         </a:buClr>
         <a:buFont typeface="Arial"/>
-        <a:defRPr b="0" i="0" sz="1400" u="none" cap="none" strike="noStrike">
+        <a:defRPr b="0" i="0" spc="0" sz="1400" u="none" cap="none" strike="noStrike">
           <a:solidFill>
             <a:srgbClr val="000000"/>
           </a:solidFill>
@@ -24961,7 +24961,7 @@
           <a:srgbClr val="000000"/>
         </a:buClr>
         <a:buFont typeface="Arial"/>
-        <a:defRPr b="0" i="0" sz="1400" u="none" cap="none" strike="noStrike">
+        <a:defRPr b="0" i="0" spc="0" sz="1400" u="none" cap="none" strike="noStrike">
           <a:solidFill>
             <a:srgbClr val="000000"/>
           </a:solidFill>
@@ -24985,7 +24985,7 @@
           <a:srgbClr val="000000"/>
         </a:buClr>
         <a:buFont typeface="Arial"/>
-        <a:defRPr b="0" i="0" sz="1400" u="none" cap="none" strike="noStrike">
+        <a:defRPr b="0" i="0" spc="0" sz="1400" u="none" cap="none" strike="noStrike">
           <a:solidFill>
             <a:srgbClr val="000000"/>
           </a:solidFill>
@@ -25009,7 +25009,7 @@
           <a:srgbClr val="000000"/>
         </a:buClr>
         <a:buFont typeface="Arial"/>
-        <a:defRPr b="0" i="0" sz="1400" u="none" cap="none" strike="noStrike">
+        <a:defRPr b="0" i="0" spc="0" sz="1400" u="none" cap="none" strike="noStrike">
           <a:solidFill>
             <a:srgbClr val="000000"/>
           </a:solidFill>
@@ -25033,7 +25033,7 @@
           <a:srgbClr val="000000"/>
         </a:buClr>
         <a:buFont typeface="Arial"/>
-        <a:defRPr b="0" i="0" sz="1400" u="none" cap="none" strike="noStrike">
+        <a:defRPr b="0" i="0" spc="0" sz="1400" u="none" cap="none" strike="noStrike">
           <a:solidFill>
             <a:srgbClr val="000000"/>
           </a:solidFill>
@@ -25057,7 +25057,7 @@
           <a:srgbClr val="000000"/>
         </a:buClr>
         <a:buFont typeface="Arial"/>
-        <a:defRPr b="0" i="0" sz="1400" u="none" cap="none" strike="noStrike">
+        <a:defRPr b="0" i="0" spc="0" sz="1400" u="none" cap="none" strike="noStrike">
           <a:solidFill>
             <a:srgbClr val="000000"/>
           </a:solidFill>
@@ -25081,7 +25081,7 @@
           <a:srgbClr val="000000"/>
         </a:buClr>
         <a:buFont typeface="Arial"/>
-        <a:defRPr b="0" i="0" sz="1400" u="none" cap="none" strike="noStrike">
+        <a:defRPr b="0" i="0" spc="0" sz="1400" u="none" cap="none" strike="noStrike">
           <a:solidFill>
             <a:srgbClr val="000000"/>
           </a:solidFill>
@@ -25105,7 +25105,7 @@
           <a:srgbClr val="000000"/>
         </a:buClr>
         <a:buFont typeface="Arial"/>
-        <a:defRPr b="0" i="0" sz="1400" u="none" cap="none" strike="noStrike">
+        <a:defRPr b="0" i="0" spc="0" sz="1400" u="none" cap="none" strike="noStrike">
           <a:solidFill>
             <a:srgbClr val="000000"/>
           </a:solidFill>
@@ -25129,7 +25129,7 @@
           <a:srgbClr val="000000"/>
         </a:buClr>
         <a:buFont typeface="Arial"/>
-        <a:defRPr b="0" i="0" sz="1400" u="none" cap="none" strike="noStrike">
+        <a:defRPr b="0" i="0" spc="0" sz="1400" u="none" cap="none" strike="noStrike">
           <a:solidFill>
             <a:srgbClr val="000000"/>
           </a:solidFill>
@@ -25153,7 +25153,7 @@
           <a:srgbClr val="000000"/>
         </a:buClr>
         <a:buFont typeface="Arial"/>
-        <a:defRPr b="0" i="0" sz="1400" u="none" cap="none" strike="noStrike">
+        <a:defRPr b="0" i="0" spc="0" sz="1400" u="none" cap="none" strike="noStrike">
           <a:solidFill>
             <a:srgbClr val="000000"/>
           </a:solidFill>
@@ -25190,7 +25190,7 @@
           <a:srgbClr val="000000"/>
         </a:buClr>
         <a:buFont typeface="Arial"/>
-        <a:defRPr b="0" i="0" sz="1400" u="none" cap="none" strike="noStrike">
+        <a:defRPr b="0" i="0" spc="0" sz="1400" u="none" cap="none" strike="noStrike">
           <a:solidFill>
             <a:srgbClr val="000000"/>
           </a:solidFill>
@@ -25214,7 +25214,7 @@
           <a:srgbClr val="000000"/>
         </a:buClr>
         <a:buFont typeface="Arial"/>
-        <a:defRPr b="0" i="0" sz="1400" u="none" cap="none" strike="noStrike">
+        <a:defRPr b="0" i="0" spc="0" sz="1400" u="none" cap="none" strike="noStrike">
           <a:solidFill>
             <a:srgbClr val="000000"/>
           </a:solidFill>
@@ -25238,7 +25238,7 @@
           <a:srgbClr val="000000"/>
         </a:buClr>
         <a:buFont typeface="Arial"/>
-        <a:defRPr b="0" i="0" sz="1400" u="none" cap="none" strike="noStrike">
+        <a:defRPr b="0" i="0" spc="0" sz="1400" u="none" cap="none" strike="noStrike">
           <a:solidFill>
             <a:srgbClr val="000000"/>
           </a:solidFill>
@@ -25262,7 +25262,7 @@
           <a:srgbClr val="000000"/>
         </a:buClr>
         <a:buFont typeface="Arial"/>
-        <a:defRPr b="0" i="0" sz="1400" u="none" cap="none" strike="noStrike">
+        <a:defRPr b="0" i="0" spc="0" sz="1400" u="none" cap="none" strike="noStrike">
           <a:solidFill>
             <a:srgbClr val="000000"/>
           </a:solidFill>
@@ -25286,7 +25286,7 @@
           <a:srgbClr val="000000"/>
         </a:buClr>
         <a:buFont typeface="Arial"/>
-        <a:defRPr b="0" i="0" sz="1400" u="none" cap="none" strike="noStrike">
+        <a:defRPr b="0" i="0" spc="0" sz="1400" u="none" cap="none" strike="noStrike">
           <a:solidFill>
             <a:srgbClr val="000000"/>
           </a:solidFill>
@@ -25310,7 +25310,7 @@
           <a:srgbClr val="000000"/>
         </a:buClr>
         <a:buFont typeface="Arial"/>
-        <a:defRPr b="0" i="0" sz="1400" u="none" cap="none" strike="noStrike">
+        <a:defRPr b="0" i="0" spc="0" sz="1400" u="none" cap="none" strike="noStrike">
           <a:solidFill>
             <a:srgbClr val="000000"/>
           </a:solidFill>
@@ -25334,7 +25334,7 @@
           <a:srgbClr val="000000"/>
         </a:buClr>
         <a:buFont typeface="Arial"/>
-        <a:defRPr b="0" i="0" sz="1400" u="none" cap="none" strike="noStrike">
+        <a:defRPr b="0" i="0" spc="0" sz="1400" u="none" cap="none" strike="noStrike">
           <a:solidFill>
             <a:srgbClr val="000000"/>
           </a:solidFill>
@@ -25358,7 +25358,7 @@
           <a:srgbClr val="000000"/>
         </a:buClr>
         <a:buFont typeface="Arial"/>
-        <a:defRPr b="0" i="0" sz="1400" u="none" cap="none" strike="noStrike">
+        <a:defRPr b="0" i="0" spc="0" sz="1400" u="none" cap="none" strike="noStrike">
           <a:solidFill>
             <a:srgbClr val="000000"/>
           </a:solidFill>
@@ -25382,7 +25382,7 @@
           <a:srgbClr val="000000"/>
         </a:buClr>
         <a:buFont typeface="Arial"/>
-        <a:defRPr b="0" i="0" sz="1400" u="none" cap="none" strike="noStrike">
+        <a:defRPr b="0" i="0" spc="0" sz="1400" u="none" cap="none" strike="noStrike">
           <a:solidFill>
             <a:srgbClr val="000000"/>
           </a:solidFill>
@@ -25419,7 +25419,7 @@
           <a:srgbClr val="000000"/>
         </a:buClr>
         <a:buFont typeface="Arial"/>
-        <a:defRPr b="0" i="0" sz="1400" u="none" cap="none" strike="noStrike">
+        <a:defRPr b="0" i="0" spc="0" sz="1400" u="none" cap="none" strike="noStrike">
           <a:solidFill>
             <a:srgbClr val="000000"/>
           </a:solidFill>
@@ -25443,7 +25443,7 @@
           <a:srgbClr val="000000"/>
         </a:buClr>
         <a:buFont typeface="Arial"/>
-        <a:defRPr b="0" i="0" sz="1400" u="none" cap="none" strike="noStrike">
+        <a:defRPr b="0" i="0" spc="0" sz="1400" u="none" cap="none" strike="noStrike">
           <a:solidFill>
             <a:srgbClr val="000000"/>
           </a:solidFill>
@@ -25467,7 +25467,7 @@
           <a:srgbClr val="000000"/>
         </a:buClr>
         <a:buFont typeface="Arial"/>
-        <a:defRPr b="0" i="0" sz="1400" u="none" cap="none" strike="noStrike">
+        <a:defRPr b="0" i="0" spc="0" sz="1400" u="none" cap="none" strike="noStrike">
           <a:solidFill>
             <a:srgbClr val="000000"/>
           </a:solidFill>
@@ -25491,7 +25491,7 @@
           <a:srgbClr val="000000"/>
         </a:buClr>
         <a:buFont typeface="Arial"/>
-        <a:defRPr b="0" i="0" sz="1400" u="none" cap="none" strike="noStrike">
+        <a:defRPr b="0" i="0" spc="0" sz="1400" u="none" cap="none" strike="noStrike">
           <a:solidFill>
             <a:srgbClr val="000000"/>
           </a:solidFill>
@@ -25515,7 +25515,7 @@
           <a:srgbClr val="000000"/>
         </a:buClr>
         <a:buFont typeface="Arial"/>
-        <a:defRPr b="0" i="0" sz="1400" u="none" cap="none" strike="noStrike">
+        <a:defRPr b="0" i="0" spc="0" sz="1400" u="none" cap="none" strike="noStrike">
           <a:solidFill>
             <a:srgbClr val="000000"/>
           </a:solidFill>
@@ -25539,7 +25539,7 @@
           <a:srgbClr val="000000"/>
         </a:buClr>
         <a:buFont typeface="Arial"/>
-        <a:defRPr b="0" i="0" sz="1400" u="none" cap="none" strike="noStrike">
+        <a:defRPr b="0" i="0" spc="0" sz="1400" u="none" cap="none" strike="noStrike">
           <a:solidFill>
             <a:srgbClr val="000000"/>
           </a:solidFill>
@@ -25563,7 +25563,7 @@
           <a:srgbClr val="000000"/>
         </a:buClr>
         <a:buFont typeface="Arial"/>
-        <a:defRPr b="0" i="0" sz="1400" u="none" cap="none" strike="noStrike">
+        <a:defRPr b="0" i="0" spc="0" sz="1400" u="none" cap="none" strike="noStrike">
           <a:solidFill>
             <a:srgbClr val="000000"/>
           </a:solidFill>
@@ -25587,7 +25587,7 @@
           <a:srgbClr val="000000"/>
         </a:buClr>
         <a:buFont typeface="Arial"/>
-        <a:defRPr b="0" i="0" sz="1400" u="none" cap="none" strike="noStrike">
+        <a:defRPr b="0" i="0" spc="0" sz="1400" u="none" cap="none" strike="noStrike">
           <a:solidFill>
             <a:srgbClr val="000000"/>
           </a:solidFill>
@@ -25611,7 +25611,7 @@
           <a:srgbClr val="000000"/>
         </a:buClr>
         <a:buFont typeface="Arial"/>
-        <a:defRPr b="0" i="0" sz="1400" u="none" cap="none" strike="noStrike">
+        <a:defRPr b="0" i="0" spc="0" sz="1400" u="none" cap="none" strike="noStrike">
           <a:solidFill>
             <a:srgbClr val="000000"/>
           </a:solidFill>
@@ -26504,7 +26504,7 @@
           <a:srgbClr val="000000"/>
         </a:buClr>
         <a:buFont typeface="Arial"/>
-        <a:defRPr b="0" i="0" sz="1400" u="none" cap="none" strike="noStrike">
+        <a:defRPr b="0" i="0" spc="0" sz="1400" u="none" cap="none" strike="noStrike">
           <a:solidFill>
             <a:srgbClr val="000000"/>
           </a:solidFill>
@@ -26528,7 +26528,7 @@
           <a:srgbClr val="000000"/>
         </a:buClr>
         <a:buFont typeface="Arial"/>
-        <a:defRPr b="0" i="0" sz="1400" u="none" cap="none" strike="noStrike">
+        <a:defRPr b="0" i="0" spc="0" sz="1400" u="none" cap="none" strike="noStrike">
           <a:solidFill>
             <a:srgbClr val="000000"/>
           </a:solidFill>
@@ -26552,7 +26552,7 @@
           <a:srgbClr val="000000"/>
         </a:buClr>
         <a:buFont typeface="Arial"/>
-        <a:defRPr b="0" i="0" sz="1400" u="none" cap="none" strike="noStrike">
+        <a:defRPr b="0" i="0" spc="0" sz="1400" u="none" cap="none" strike="noStrike">
           <a:solidFill>
             <a:srgbClr val="000000"/>
           </a:solidFill>
@@ -26576,7 +26576,7 @@
           <a:srgbClr val="000000"/>
         </a:buClr>
         <a:buFont typeface="Arial"/>
-        <a:defRPr b="0" i="0" sz="1400" u="none" cap="none" strike="noStrike">
+        <a:defRPr b="0" i="0" spc="0" sz="1400" u="none" cap="none" strike="noStrike">
           <a:solidFill>
             <a:srgbClr val="000000"/>
           </a:solidFill>
@@ -26600,7 +26600,7 @@
           <a:srgbClr val="000000"/>
         </a:buClr>
         <a:buFont typeface="Arial"/>
-        <a:defRPr b="0" i="0" sz="1400" u="none" cap="none" strike="noStrike">
+        <a:defRPr b="0" i="0" spc="0" sz="1400" u="none" cap="none" strike="noStrike">
           <a:solidFill>
             <a:srgbClr val="000000"/>
           </a:solidFill>
@@ -26624,7 +26624,7 @@
           <a:srgbClr val="000000"/>
         </a:buClr>
         <a:buFont typeface="Arial"/>
-        <a:defRPr b="0" i="0" sz="1400" u="none" cap="none" strike="noStrike">
+        <a:defRPr b="0" i="0" spc="0" sz="1400" u="none" cap="none" strike="noStrike">
           <a:solidFill>
             <a:srgbClr val="000000"/>
           </a:solidFill>
@@ -26648,7 +26648,7 @@
           <a:srgbClr val="000000"/>
         </a:buClr>
         <a:buFont typeface="Arial"/>
-        <a:defRPr b="0" i="0" sz="1400" u="none" cap="none" strike="noStrike">
+        <a:defRPr b="0" i="0" spc="0" sz="1400" u="none" cap="none" strike="noStrike">
           <a:solidFill>
             <a:srgbClr val="000000"/>
           </a:solidFill>
@@ -26672,7 +26672,7 @@
           <a:srgbClr val="000000"/>
         </a:buClr>
         <a:buFont typeface="Arial"/>
-        <a:defRPr b="0" i="0" sz="1400" u="none" cap="none" strike="noStrike">
+        <a:defRPr b="0" i="0" spc="0" sz="1400" u="none" cap="none" strike="noStrike">
           <a:solidFill>
             <a:srgbClr val="000000"/>
           </a:solidFill>
@@ -26696,7 +26696,7 @@
           <a:srgbClr val="000000"/>
         </a:buClr>
         <a:buFont typeface="Arial"/>
-        <a:defRPr b="0" i="0" sz="1400" u="none" cap="none" strike="noStrike">
+        <a:defRPr b="0" i="0" spc="0" sz="1400" u="none" cap="none" strike="noStrike">
           <a:solidFill>
             <a:srgbClr val="000000"/>
           </a:solidFill>
@@ -26733,7 +26733,7 @@
           <a:srgbClr val="000000"/>
         </a:buClr>
         <a:buFont typeface="Arial"/>
-        <a:defRPr b="0" i="0" sz="1400" u="none" cap="none" strike="noStrike">
+        <a:defRPr b="0" i="0" spc="0" sz="1400" u="none" cap="none" strike="noStrike">
           <a:solidFill>
             <a:srgbClr val="000000"/>
           </a:solidFill>
@@ -26757,7 +26757,7 @@
           <a:srgbClr val="000000"/>
         </a:buClr>
         <a:buFont typeface="Arial"/>
-        <a:defRPr b="0" i="0" sz="1400" u="none" cap="none" strike="noStrike">
+        <a:defRPr b="0" i="0" spc="0" sz="1400" u="none" cap="none" strike="noStrike">
           <a:solidFill>
             <a:srgbClr val="000000"/>
           </a:solidFill>
@@ -26781,7 +26781,7 @@
           <a:srgbClr val="000000"/>
         </a:buClr>
         <a:buFont typeface="Arial"/>
-        <a:defRPr b="0" i="0" sz="1400" u="none" cap="none" strike="noStrike">
+        <a:defRPr b="0" i="0" spc="0" sz="1400" u="none" cap="none" strike="noStrike">
           <a:solidFill>
             <a:srgbClr val="000000"/>
           </a:solidFill>
@@ -26805,7 +26805,7 @@
           <a:srgbClr val="000000"/>
         </a:buClr>
         <a:buFont typeface="Arial"/>
-        <a:defRPr b="0" i="0" sz="1400" u="none" cap="none" strike="noStrike">
+        <a:defRPr b="0" i="0" spc="0" sz="1400" u="none" cap="none" strike="noStrike">
           <a:solidFill>
             <a:srgbClr val="000000"/>
           </a:solidFill>
@@ -26829,7 +26829,7 @@
           <a:srgbClr val="000000"/>
         </a:buClr>
         <a:buFont typeface="Arial"/>
-        <a:defRPr b="0" i="0" sz="1400" u="none" cap="none" strike="noStrike">
+        <a:defRPr b="0" i="0" spc="0" sz="1400" u="none" cap="none" strike="noStrike">
           <a:solidFill>
             <a:srgbClr val="000000"/>
           </a:solidFill>
@@ -26853,7 +26853,7 @@
           <a:srgbClr val="000000"/>
         </a:buClr>
         <a:buFont typeface="Arial"/>
-        <a:defRPr b="0" i="0" sz="1400" u="none" cap="none" strike="noStrike">
+        <a:defRPr b="0" i="0" spc="0" sz="1400" u="none" cap="none" strike="noStrike">
           <a:solidFill>
             <a:srgbClr val="000000"/>
           </a:solidFill>
@@ -26877,7 +26877,7 @@
           <a:srgbClr val="000000"/>
         </a:buClr>
         <a:buFont typeface="Arial"/>
-        <a:defRPr b="0" i="0" sz="1400" u="none" cap="none" strike="noStrike">
+        <a:defRPr b="0" i="0" spc="0" sz="1400" u="none" cap="none" strike="noStrike">
           <a:solidFill>
             <a:srgbClr val="000000"/>
           </a:solidFill>
@@ -26901,7 +26901,7 @@
           <a:srgbClr val="000000"/>
         </a:buClr>
         <a:buFont typeface="Arial"/>
-        <a:defRPr b="0" i="0" sz="1400" u="none" cap="none" strike="noStrike">
+        <a:defRPr b="0" i="0" spc="0" sz="1400" u="none" cap="none" strike="noStrike">
           <a:solidFill>
             <a:srgbClr val="000000"/>
           </a:solidFill>
@@ -26925,7 +26925,7 @@
           <a:srgbClr val="000000"/>
         </a:buClr>
         <a:buFont typeface="Arial"/>
-        <a:defRPr b="0" i="0" sz="1400" u="none" cap="none" strike="noStrike">
+        <a:defRPr b="0" i="0" spc="0" sz="1400" u="none" cap="none" strike="noStrike">
           <a:solidFill>
             <a:srgbClr val="000000"/>
           </a:solidFill>
@@ -26962,7 +26962,7 @@
           <a:srgbClr val="000000"/>
         </a:buClr>
         <a:buFont typeface="Arial"/>
-        <a:defRPr b="0" i="0" sz="1400" u="none" cap="none" strike="noStrike">
+        <a:defRPr b="0" i="0" spc="0" sz="1400" u="none" cap="none" strike="noStrike">
           <a:solidFill>
             <a:srgbClr val="000000"/>
           </a:solidFill>
@@ -26986,7 +26986,7 @@
           <a:srgbClr val="000000"/>
         </a:buClr>
         <a:buFont typeface="Arial"/>
-        <a:defRPr b="0" i="0" sz="1400" u="none" cap="none" strike="noStrike">
+        <a:defRPr b="0" i="0" spc="0" sz="1400" u="none" cap="none" strike="noStrike">
           <a:solidFill>
             <a:srgbClr val="000000"/>
           </a:solidFill>
@@ -27010,7 +27010,7 @@
           <a:srgbClr val="000000"/>
         </a:buClr>
         <a:buFont typeface="Arial"/>
-        <a:defRPr b="0" i="0" sz="1400" u="none" cap="none" strike="noStrike">
+        <a:defRPr b="0" i="0" spc="0" sz="1400" u="none" cap="none" strike="noStrike">
           <a:solidFill>
             <a:srgbClr val="000000"/>
           </a:solidFill>
@@ -27034,7 +27034,7 @@
           <a:srgbClr val="000000"/>
         </a:buClr>
         <a:buFont typeface="Arial"/>
-        <a:defRPr b="0" i="0" sz="1400" u="none" cap="none" strike="noStrike">
+        <a:defRPr b="0" i="0" spc="0" sz="1400" u="none" cap="none" strike="noStrike">
           <a:solidFill>
             <a:srgbClr val="000000"/>
           </a:solidFill>
@@ -27058,7 +27058,7 @@
           <a:srgbClr val="000000"/>
         </a:buClr>
         <a:buFont typeface="Arial"/>
-        <a:defRPr b="0" i="0" sz="1400" u="none" cap="none" strike="noStrike">
+        <a:defRPr b="0" i="0" spc="0" sz="1400" u="none" cap="none" strike="noStrike">
           <a:solidFill>
             <a:srgbClr val="000000"/>
           </a:solidFill>
@@ -27082,7 +27082,7 @@
           <a:srgbClr val="000000"/>
         </a:buClr>
         <a:buFont typeface="Arial"/>
-        <a:defRPr b="0" i="0" sz="1400" u="none" cap="none" strike="noStrike">
+        <a:defRPr b="0" i="0" spc="0" sz="1400" u="none" cap="none" strike="noStrike">
           <a:solidFill>
             <a:srgbClr val="000000"/>
           </a:solidFill>
@@ -27106,7 +27106,7 @@
           <a:srgbClr val="000000"/>
         </a:buClr>
         <a:buFont typeface="Arial"/>
-        <a:defRPr b="0" i="0" sz="1400" u="none" cap="none" strike="noStrike">
+        <a:defRPr b="0" i="0" spc="0" sz="1400" u="none" cap="none" strike="noStrike">
           <a:solidFill>
             <a:srgbClr val="000000"/>
           </a:solidFill>
@@ -27130,7 +27130,7 @@
           <a:srgbClr val="000000"/>
         </a:buClr>
         <a:buFont typeface="Arial"/>
-        <a:defRPr b="0" i="0" sz="1400" u="none" cap="none" strike="noStrike">
+        <a:defRPr b="0" i="0" spc="0" sz="1400" u="none" cap="none" strike="noStrike">
           <a:solidFill>
             <a:srgbClr val="000000"/>
           </a:solidFill>
@@ -27154,7 +27154,7 @@
           <a:srgbClr val="000000"/>
         </a:buClr>
         <a:buFont typeface="Arial"/>
-        <a:defRPr b="0" i="0" sz="1400" u="none" cap="none" strike="noStrike">
+        <a:defRPr b="0" i="0" spc="0" sz="1400" u="none" cap="none" strike="noStrike">
           <a:solidFill>
             <a:srgbClr val="000000"/>
           </a:solidFill>
@@ -27219,7 +27219,7 @@
             <a:normAutofit/>
           </a:bodyPr>
           <a:lstStyle>
-            <a:lvl1pPr lvl="0" marR="0" rtl="0" algn="l">
+            <a:lvl1pPr lvl="0" marR="0" algn="l">
               <a:lnSpc>
                 <a:spcPct val="100000"/>
               </a:lnSpc>
@@ -27245,7 +27245,7 @@
                 <a:sym typeface="Arial"/>
               </a:defRPr>
             </a:lvl1pPr>
-            <a:lvl2pPr lvl="1" marR="0" rtl="0" algn="l">
+            <a:lvl2pPr lvl="1" marR="0" algn="l">
               <a:lnSpc>
                 <a:spcPct val="100000"/>
               </a:lnSpc>
@@ -27271,7 +27271,7 @@
                 <a:sym typeface="Arial"/>
               </a:defRPr>
             </a:lvl2pPr>
-            <a:lvl3pPr lvl="2" marR="0" rtl="0" algn="l">
+            <a:lvl3pPr lvl="2" marR="0" algn="l">
               <a:lnSpc>
                 <a:spcPct val="100000"/>
               </a:lnSpc>
@@ -27297,7 +27297,7 @@
                 <a:sym typeface="Arial"/>
               </a:defRPr>
             </a:lvl3pPr>
-            <a:lvl4pPr lvl="3" marR="0" rtl="0" algn="l">
+            <a:lvl4pPr lvl="3" marR="0" algn="l">
               <a:lnSpc>
                 <a:spcPct val="100000"/>
               </a:lnSpc>
@@ -27323,7 +27323,7 @@
                 <a:sym typeface="Arial"/>
               </a:defRPr>
             </a:lvl4pPr>
-            <a:lvl5pPr lvl="4" marR="0" rtl="0" algn="l">
+            <a:lvl5pPr lvl="4" marR="0" algn="l">
               <a:lnSpc>
                 <a:spcPct val="100000"/>
               </a:lnSpc>
@@ -27349,7 +27349,7 @@
                 <a:sym typeface="Arial"/>
               </a:defRPr>
             </a:lvl5pPr>
-            <a:lvl6pPr lvl="5" marR="0" rtl="0" algn="l">
+            <a:lvl6pPr lvl="5" marR="0" algn="l">
               <a:lnSpc>
                 <a:spcPct val="100000"/>
               </a:lnSpc>
@@ -27375,7 +27375,7 @@
                 <a:sym typeface="Arial"/>
               </a:defRPr>
             </a:lvl6pPr>
-            <a:lvl7pPr lvl="6" marR="0" rtl="0" algn="l">
+            <a:lvl7pPr lvl="6" marR="0" algn="l">
               <a:lnSpc>
                 <a:spcPct val="100000"/>
               </a:lnSpc>
@@ -27401,7 +27401,7 @@
                 <a:sym typeface="Arial"/>
               </a:defRPr>
             </a:lvl7pPr>
-            <a:lvl8pPr lvl="7" marR="0" rtl="0" algn="l">
+            <a:lvl8pPr lvl="7" marR="0" algn="l">
               <a:lnSpc>
                 <a:spcPct val="100000"/>
               </a:lnSpc>
@@ -27427,7 +27427,7 @@
                 <a:sym typeface="Arial"/>
               </a:defRPr>
             </a:lvl8pPr>
-            <a:lvl9pPr lvl="8" marR="0" rtl="0" algn="l">
+            <a:lvl9pPr lvl="8" marR="0" algn="l">
               <a:lnSpc>
                 <a:spcPct val="100000"/>
               </a:lnSpc>
@@ -27483,7 +27483,7 @@
             <a:normAutofit/>
           </a:bodyPr>
           <a:lstStyle>
-            <a:lvl1pPr indent="-342900" lvl="0" marL="457200" marR="0" rtl="0" algn="l">
+            <a:lvl1pPr indent="-342900" lvl="0" marL="457200" marR="0" algn="l">
               <a:lnSpc>
                 <a:spcPct val="115000"/>
               </a:lnSpc>
@@ -27509,7 +27509,7 @@
                 <a:sym typeface="Arial"/>
               </a:defRPr>
             </a:lvl1pPr>
-            <a:lvl2pPr indent="-317500" lvl="1" marL="914400" marR="0" rtl="0" algn="l">
+            <a:lvl2pPr indent="-317500" lvl="1" marL="914400" marR="0" algn="l">
               <a:lnSpc>
                 <a:spcPct val="115000"/>
               </a:lnSpc>
@@ -27535,7 +27535,7 @@
                 <a:sym typeface="Arial"/>
               </a:defRPr>
             </a:lvl2pPr>
-            <a:lvl3pPr indent="-317500" lvl="2" marL="1371600" marR="0" rtl="0" algn="l">
+            <a:lvl3pPr indent="-317500" lvl="2" marL="1371600" marR="0" algn="l">
               <a:lnSpc>
                 <a:spcPct val="115000"/>
               </a:lnSpc>
@@ -27561,7 +27561,7 @@
                 <a:sym typeface="Arial"/>
               </a:defRPr>
             </a:lvl3pPr>
-            <a:lvl4pPr indent="-317500" lvl="3" marL="1828800" marR="0" rtl="0" algn="l">
+            <a:lvl4pPr indent="-317500" lvl="3" marL="1828800" marR="0" algn="l">
               <a:lnSpc>
                 <a:spcPct val="115000"/>
               </a:lnSpc>
@@ -27587,7 +27587,7 @@
                 <a:sym typeface="Arial"/>
               </a:defRPr>
             </a:lvl4pPr>
-            <a:lvl5pPr indent="-317500" lvl="4" marL="2286000" marR="0" rtl="0" algn="l">
+            <a:lvl5pPr indent="-317500" lvl="4" marL="2286000" marR="0" algn="l">
               <a:lnSpc>
                 <a:spcPct val="115000"/>
               </a:lnSpc>
@@ -27613,7 +27613,7 @@
                 <a:sym typeface="Arial"/>
               </a:defRPr>
             </a:lvl5pPr>
-            <a:lvl6pPr indent="-317500" lvl="5" marL="2743200" marR="0" rtl="0" algn="l">
+            <a:lvl6pPr indent="-317500" lvl="5" marL="2743200" marR="0" algn="l">
               <a:lnSpc>
                 <a:spcPct val="115000"/>
               </a:lnSpc>
@@ -27639,7 +27639,7 @@
                 <a:sym typeface="Arial"/>
               </a:defRPr>
             </a:lvl6pPr>
-            <a:lvl7pPr indent="-317500" lvl="6" marL="3200400" marR="0" rtl="0" algn="l">
+            <a:lvl7pPr indent="-317500" lvl="6" marL="3200400" marR="0" algn="l">
               <a:lnSpc>
                 <a:spcPct val="115000"/>
               </a:lnSpc>
@@ -27665,7 +27665,7 @@
                 <a:sym typeface="Arial"/>
               </a:defRPr>
             </a:lvl7pPr>
-            <a:lvl8pPr indent="-317500" lvl="7" marL="3657600" marR="0" rtl="0" algn="l">
+            <a:lvl8pPr indent="-317500" lvl="7" marL="3657600" marR="0" algn="l">
               <a:lnSpc>
                 <a:spcPct val="115000"/>
               </a:lnSpc>
@@ -27691,7 +27691,7 @@
                 <a:sym typeface="Arial"/>
               </a:defRPr>
             </a:lvl8pPr>
-            <a:lvl9pPr indent="-317500" lvl="8" marL="4114800" marR="0" rtl="0" algn="l">
+            <a:lvl9pPr indent="-317500" lvl="8" marL="4114800" marR="0" algn="l">
               <a:lnSpc>
                 <a:spcPct val="115000"/>
               </a:lnSpc>
@@ -27747,7 +27747,7 @@
             <a:normAutofit/>
           </a:bodyPr>
           <a:lstStyle>
-            <a:lvl1pPr indent="0" lvl="0" marL="0" marR="0" rtl="0" algn="r">
+            <a:lvl1pPr indent="0" lvl="0" marL="0" marR="0" algn="r">
               <a:lnSpc>
                 <a:spcPct val="100000"/>
               </a:lnSpc>
@@ -27773,7 +27773,7 @@
                 <a:sym typeface="Arial"/>
               </a:defRPr>
             </a:lvl1pPr>
-            <a:lvl2pPr indent="0" lvl="1" marL="0" marR="0" rtl="0" algn="r">
+            <a:lvl2pPr indent="0" lvl="1" marL="0" marR="0" algn="r">
               <a:lnSpc>
                 <a:spcPct val="100000"/>
               </a:lnSpc>
@@ -27799,7 +27799,7 @@
                 <a:sym typeface="Arial"/>
               </a:defRPr>
             </a:lvl2pPr>
-            <a:lvl3pPr indent="0" lvl="2" marL="0" marR="0" rtl="0" algn="r">
+            <a:lvl3pPr indent="0" lvl="2" marL="0" marR="0" algn="r">
               <a:lnSpc>
                 <a:spcPct val="100000"/>
               </a:lnSpc>
@@ -27825,7 +27825,7 @@
                 <a:sym typeface="Arial"/>
               </a:defRPr>
             </a:lvl3pPr>
-            <a:lvl4pPr indent="0" lvl="3" marL="0" marR="0" rtl="0" algn="r">
+            <a:lvl4pPr indent="0" lvl="3" marL="0" marR="0" algn="r">
               <a:lnSpc>
                 <a:spcPct val="100000"/>
               </a:lnSpc>
@@ -27851,7 +27851,7 @@
                 <a:sym typeface="Arial"/>
               </a:defRPr>
             </a:lvl4pPr>
-            <a:lvl5pPr indent="0" lvl="4" marL="0" marR="0" rtl="0" algn="r">
+            <a:lvl5pPr indent="0" lvl="4" marL="0" marR="0" algn="r">
               <a:lnSpc>
                 <a:spcPct val="100000"/>
               </a:lnSpc>
@@ -27877,7 +27877,7 @@
                 <a:sym typeface="Arial"/>
               </a:defRPr>
             </a:lvl5pPr>
-            <a:lvl6pPr indent="0" lvl="5" marL="0" marR="0" rtl="0" algn="r">
+            <a:lvl6pPr indent="0" lvl="5" marL="0" marR="0" algn="r">
               <a:lnSpc>
                 <a:spcPct val="100000"/>
               </a:lnSpc>
@@ -27903,7 +27903,7 @@
                 <a:sym typeface="Arial"/>
               </a:defRPr>
             </a:lvl6pPr>
-            <a:lvl7pPr indent="0" lvl="6" marL="0" marR="0" rtl="0" algn="r">
+            <a:lvl7pPr indent="0" lvl="6" marL="0" marR="0" algn="r">
               <a:lnSpc>
                 <a:spcPct val="100000"/>
               </a:lnSpc>
@@ -27929,7 +27929,7 @@
                 <a:sym typeface="Arial"/>
               </a:defRPr>
             </a:lvl7pPr>
-            <a:lvl8pPr indent="0" lvl="7" marL="0" marR="0" rtl="0" algn="r">
+            <a:lvl8pPr indent="0" lvl="7" marL="0" marR="0" algn="r">
               <a:lnSpc>
                 <a:spcPct val="100000"/>
               </a:lnSpc>
@@ -27955,7 +27955,7 @@
                 <a:sym typeface="Arial"/>
               </a:defRPr>
             </a:lvl8pPr>
-            <a:lvl9pPr indent="0" lvl="8" marL="0" marR="0" rtl="0" algn="r">
+            <a:lvl9pPr indent="0" lvl="8" marL="0" marR="0" algn="r">
               <a:lnSpc>
                 <a:spcPct val="100000"/>
               </a:lnSpc>
@@ -28044,7 +28044,7 @@
           <a:srgbClr val="000000"/>
         </a:buClr>
         <a:buFont typeface="Arial"/>
-        <a:defRPr b="0" i="0" sz="1400" u="none" cap="none" strike="noStrike">
+        <a:defRPr b="0" i="0" spc="0" sz="1400" u="none" cap="none" strike="noStrike">
           <a:solidFill>
             <a:srgbClr val="000000"/>
           </a:solidFill>
@@ -28068,7 +28068,7 @@
           <a:srgbClr val="000000"/>
         </a:buClr>
         <a:buFont typeface="Arial"/>
-        <a:defRPr b="0" i="0" sz="1400" u="none" cap="none" strike="noStrike">
+        <a:defRPr b="0" i="0" spc="0" sz="1400" u="none" cap="none" strike="noStrike">
           <a:solidFill>
             <a:srgbClr val="000000"/>
           </a:solidFill>
@@ -28092,7 +28092,7 @@
           <a:srgbClr val="000000"/>
         </a:buClr>
         <a:buFont typeface="Arial"/>
-        <a:defRPr b="0" i="0" sz="1400" u="none" cap="none" strike="noStrike">
+        <a:defRPr b="0" i="0" spc="0" sz="1400" u="none" cap="none" strike="noStrike">
           <a:solidFill>
             <a:srgbClr val="000000"/>
           </a:solidFill>
@@ -28116,7 +28116,7 @@
           <a:srgbClr val="000000"/>
         </a:buClr>
         <a:buFont typeface="Arial"/>
-        <a:defRPr b="0" i="0" sz="1400" u="none" cap="none" strike="noStrike">
+        <a:defRPr b="0" i="0" spc="0" sz="1400" u="none" cap="none" strike="noStrike">
           <a:solidFill>
             <a:srgbClr val="000000"/>
           </a:solidFill>
@@ -28140,7 +28140,7 @@
           <a:srgbClr val="000000"/>
         </a:buClr>
         <a:buFont typeface="Arial"/>
-        <a:defRPr b="0" i="0" sz="1400" u="none" cap="none" strike="noStrike">
+        <a:defRPr b="0" i="0" spc="0" sz="1400" u="none" cap="none" strike="noStrike">
           <a:solidFill>
             <a:srgbClr val="000000"/>
           </a:solidFill>
@@ -28164,7 +28164,7 @@
           <a:srgbClr val="000000"/>
         </a:buClr>
         <a:buFont typeface="Arial"/>
-        <a:defRPr b="0" i="0" sz="1400" u="none" cap="none" strike="noStrike">
+        <a:defRPr b="0" i="0" spc="0" sz="1400" u="none" cap="none" strike="noStrike">
           <a:solidFill>
             <a:srgbClr val="000000"/>
           </a:solidFill>
@@ -28188,7 +28188,7 @@
           <a:srgbClr val="000000"/>
         </a:buClr>
         <a:buFont typeface="Arial"/>
-        <a:defRPr b="0" i="0" sz="1400" u="none" cap="none" strike="noStrike">
+        <a:defRPr b="0" i="0" spc="0" sz="1400" u="none" cap="none" strike="noStrike">
           <a:solidFill>
             <a:srgbClr val="000000"/>
           </a:solidFill>
@@ -28212,7 +28212,7 @@
           <a:srgbClr val="000000"/>
         </a:buClr>
         <a:buFont typeface="Arial"/>
-        <a:defRPr b="0" i="0" sz="1400" u="none" cap="none" strike="noStrike">
+        <a:defRPr b="0" i="0" spc="0" sz="1400" u="none" cap="none" strike="noStrike">
           <a:solidFill>
             <a:srgbClr val="000000"/>
           </a:solidFill>
@@ -28236,7 +28236,7 @@
           <a:srgbClr val="000000"/>
         </a:buClr>
         <a:buFont typeface="Arial"/>
-        <a:defRPr b="0" i="0" sz="1400" u="none" cap="none" strike="noStrike">
+        <a:defRPr b="0" i="0" spc="0" sz="1400" u="none" cap="none" strike="noStrike">
           <a:solidFill>
             <a:srgbClr val="000000"/>
           </a:solidFill>
@@ -28273,7 +28273,7 @@
           <a:srgbClr val="000000"/>
         </a:buClr>
         <a:buFont typeface="Arial"/>
-        <a:defRPr b="0" i="0" sz="1400" u="none" cap="none" strike="noStrike">
+        <a:defRPr b="0" i="0" spc="0" sz="1400" u="none" cap="none" strike="noStrike">
           <a:solidFill>
             <a:srgbClr val="000000"/>
           </a:solidFill>
@@ -28297,7 +28297,7 @@
           <a:srgbClr val="000000"/>
         </a:buClr>
         <a:buFont typeface="Arial"/>
-        <a:defRPr b="0" i="0" sz="1400" u="none" cap="none" strike="noStrike">
+        <a:defRPr b="0" i="0" spc="0" sz="1400" u="none" cap="none" strike="noStrike">
           <a:solidFill>
             <a:srgbClr val="000000"/>
           </a:solidFill>
@@ -28321,7 +28321,7 @@
           <a:srgbClr val="000000"/>
         </a:buClr>
         <a:buFont typeface="Arial"/>
-        <a:defRPr b="0" i="0" sz="1400" u="none" cap="none" strike="noStrike">
+        <a:defRPr b="0" i="0" spc="0" sz="1400" u="none" cap="none" strike="noStrike">
           <a:solidFill>
             <a:srgbClr val="000000"/>
           </a:solidFill>
@@ -28345,7 +28345,7 @@
           <a:srgbClr val="000000"/>
         </a:buClr>
         <a:buFont typeface="Arial"/>
-        <a:defRPr b="0" i="0" sz="1400" u="none" cap="none" strike="noStrike">
+        <a:defRPr b="0" i="0" spc="0" sz="1400" u="none" cap="none" strike="noStrike">
           <a:solidFill>
             <a:srgbClr val="000000"/>
           </a:solidFill>
@@ -28369,7 +28369,7 @@
           <a:srgbClr val="000000"/>
         </a:buClr>
         <a:buFont typeface="Arial"/>
-        <a:defRPr b="0" i="0" sz="1400" u="none" cap="none" strike="noStrike">
+        <a:defRPr b="0" i="0" spc="0" sz="1400" u="none" cap="none" strike="noStrike">
           <a:solidFill>
             <a:srgbClr val="000000"/>
           </a:solidFill>
@@ -28393,7 +28393,7 @@
           <a:srgbClr val="000000"/>
         </a:buClr>
         <a:buFont typeface="Arial"/>
-        <a:defRPr b="0" i="0" sz="1400" u="none" cap="none" strike="noStrike">
+        <a:defRPr b="0" i="0" spc="0" sz="1400" u="none" cap="none" strike="noStrike">
           <a:solidFill>
             <a:srgbClr val="000000"/>
           </a:solidFill>
@@ -28417,7 +28417,7 @@
           <a:srgbClr val="000000"/>
         </a:buClr>
         <a:buFont typeface="Arial"/>
-        <a:defRPr b="0" i="0" sz="1400" u="none" cap="none" strike="noStrike">
+        <a:defRPr b="0" i="0" spc="0" sz="1400" u="none" cap="none" strike="noStrike">
           <a:solidFill>
             <a:srgbClr val="000000"/>
           </a:solidFill>
@@ -28441,7 +28441,7 @@
           <a:srgbClr val="000000"/>
         </a:buClr>
         <a:buFont typeface="Arial"/>
-        <a:defRPr b="0" i="0" sz="1400" u="none" cap="none" strike="noStrike">
+        <a:defRPr b="0" i="0" spc="0" sz="1400" u="none" cap="none" strike="noStrike">
           <a:solidFill>
             <a:srgbClr val="000000"/>
           </a:solidFill>
@@ -28465,7 +28465,7 @@
           <a:srgbClr val="000000"/>
         </a:buClr>
         <a:buFont typeface="Arial"/>
-        <a:defRPr b="0" i="0" sz="1400" u="none" cap="none" strike="noStrike">
+        <a:defRPr b="0" i="0" spc="0" sz="1400" u="none" cap="none" strike="noStrike">
           <a:solidFill>
             <a:srgbClr val="000000"/>
           </a:solidFill>
@@ -28502,7 +28502,7 @@
           <a:srgbClr val="000000"/>
         </a:buClr>
         <a:buFont typeface="Arial"/>
-        <a:defRPr b="0" i="0" sz="1400" u="none" cap="none" strike="noStrike">
+        <a:defRPr b="0" i="0" spc="0" sz="1400" u="none" cap="none" strike="noStrike">
           <a:solidFill>
             <a:srgbClr val="000000"/>
           </a:solidFill>
@@ -28526,7 +28526,7 @@
           <a:srgbClr val="000000"/>
         </a:buClr>
         <a:buFont typeface="Arial"/>
-        <a:defRPr b="0" i="0" sz="1400" u="none" cap="none" strike="noStrike">
+        <a:defRPr b="0" i="0" spc="0" sz="1400" u="none" cap="none" strike="noStrike">
           <a:solidFill>
             <a:srgbClr val="000000"/>
           </a:solidFill>
@@ -28550,7 +28550,7 @@
           <a:srgbClr val="000000"/>
         </a:buClr>
         <a:buFont typeface="Arial"/>
-        <a:defRPr b="0" i="0" sz="1400" u="none" cap="none" strike="noStrike">
+        <a:defRPr b="0" i="0" spc="0" sz="1400" u="none" cap="none" strike="noStrike">
           <a:solidFill>
             <a:srgbClr val="000000"/>
           </a:solidFill>
@@ -28574,7 +28574,7 @@
           <a:srgbClr val="000000"/>
         </a:buClr>
         <a:buFont typeface="Arial"/>
-        <a:defRPr b="0" i="0" sz="1400" u="none" cap="none" strike="noStrike">
+        <a:defRPr b="0" i="0" spc="0" sz="1400" u="none" cap="none" strike="noStrike">
           <a:solidFill>
             <a:srgbClr val="000000"/>
           </a:solidFill>
@@ -28598,7 +28598,7 @@
           <a:srgbClr val="000000"/>
         </a:buClr>
         <a:buFont typeface="Arial"/>
-        <a:defRPr b="0" i="0" sz="1400" u="none" cap="none" strike="noStrike">
+        <a:defRPr b="0" i="0" spc="0" sz="1400" u="none" cap="none" strike="noStrike">
           <a:solidFill>
             <a:srgbClr val="000000"/>
           </a:solidFill>
@@ -28622,7 +28622,7 @@
           <a:srgbClr val="000000"/>
         </a:buClr>
         <a:buFont typeface="Arial"/>
-        <a:defRPr b="0" i="0" sz="1400" u="none" cap="none" strike="noStrike">
+        <a:defRPr b="0" i="0" spc="0" sz="1400" u="none" cap="none" strike="noStrike">
           <a:solidFill>
             <a:srgbClr val="000000"/>
           </a:solidFill>
@@ -28646,7 +28646,7 @@
           <a:srgbClr val="000000"/>
         </a:buClr>
         <a:buFont typeface="Arial"/>
-        <a:defRPr b="0" i="0" sz="1400" u="none" cap="none" strike="noStrike">
+        <a:defRPr b="0" i="0" spc="0" sz="1400" u="none" cap="none" strike="noStrike">
           <a:solidFill>
             <a:srgbClr val="000000"/>
           </a:solidFill>
@@ -28670,7 +28670,7 @@
           <a:srgbClr val="000000"/>
         </a:buClr>
         <a:buFont typeface="Arial"/>
-        <a:defRPr b="0" i="0" sz="1400" u="none" cap="none" strike="noStrike">
+        <a:defRPr b="0" i="0" spc="0" sz="1400" u="none" cap="none" strike="noStrike">
           <a:solidFill>
             <a:srgbClr val="000000"/>
           </a:solidFill>
@@ -28694,7 +28694,7 @@
           <a:srgbClr val="000000"/>
         </a:buClr>
         <a:buFont typeface="Arial"/>
-        <a:defRPr b="0" i="0" sz="1400" u="none" cap="none" strike="noStrike">
+        <a:defRPr b="0" i="0" spc="0" sz="1400" u="none" cap="none" strike="noStrike">
           <a:solidFill>
             <a:srgbClr val="000000"/>
           </a:solidFill>
@@ -36813,7 +36813,7 @@
             <a:tbl>
               <a:tblPr>
                 <a:noFill/>
-                <a:tableStyleId>{7105D537-239D-4BBD-A6FD-BB8609C5E33B}</a:tableStyleId>
+                <a:tableStyleId>{3490F3D7-4271-4291-8D71-B0AB4515BED5}</a:tableStyleId>
               </a:tblPr>
               <a:tblGrid>
                 <a:gridCol w="1188725"/>
@@ -38390,7 +38390,7 @@
           <a:effectLst>
             <a:outerShdw blurRad="50800" rotWithShape="0" algn="bl" dir="8100000" dist="25400">
               <a:srgbClr val="000000">
-                <a:alpha val="7843"/>
+                <a:alpha val="7840"/>
               </a:srgbClr>
             </a:outerShdw>
           </a:effectLst>
@@ -38647,7 +38647,7 @@
           <a:effectLst>
             <a:outerShdw blurRad="50800" rotWithShape="0" algn="bl" dir="8100000" dist="25400">
               <a:srgbClr val="000000">
-                <a:alpha val="7843"/>
+                <a:alpha val="7840"/>
               </a:srgbClr>
             </a:outerShdw>
           </a:effectLst>
@@ -38904,7 +38904,7 @@
           <a:effectLst>
             <a:outerShdw blurRad="50800" rotWithShape="0" algn="bl" dir="8100000" dist="25400">
               <a:srgbClr val="000000">
-                <a:alpha val="7843"/>
+                <a:alpha val="7840"/>
               </a:srgbClr>
             </a:outerShdw>
           </a:effectLst>
@@ -39161,7 +39161,7 @@
           <a:effectLst>
             <a:outerShdw blurRad="50800" rotWithShape="0" algn="bl" dir="8100000" dist="25400">
               <a:srgbClr val="000000">
-                <a:alpha val="7843"/>
+                <a:alpha val="7840"/>
               </a:srgbClr>
             </a:outerShdw>
           </a:effectLst>
@@ -39418,7 +39418,7 @@
           <a:effectLst>
             <a:outerShdw blurRad="50800" rotWithShape="0" algn="bl" dir="8100000" dist="25400">
               <a:srgbClr val="000000">
-                <a:alpha val="7843"/>
+                <a:alpha val="7840"/>
               </a:srgbClr>
             </a:outerShdw>
           </a:effectLst>
@@ -39675,7 +39675,7 @@
           <a:effectLst>
             <a:outerShdw blurRad="50800" rotWithShape="0" algn="bl" dir="8100000" dist="25400">
               <a:srgbClr val="000000">
-                <a:alpha val="7843"/>
+                <a:alpha val="7840"/>
               </a:srgbClr>
             </a:outerShdw>
           </a:effectLst>
@@ -54734,9 +54734,9 @@
 </file>
 
 <file path=ppt/theme/theme1.xml><?xml version="1.0" encoding="utf-8"?>
-<a:theme xmlns:a="http://schemas.openxmlformats.org/drawingml/2006/main" xmlns:r="http://schemas.openxmlformats.org/officeDocument/2006/relationships">
+<a:theme xmlns:a="http://schemas.openxmlformats.org/drawingml/2006/main" xmlns:r="http://schemas.openxmlformats.org/officeDocument/2006/relationships" name="Simple Light">
   <a:themeElements>
-    <a:clrScheme name="Default">
+    <a:clrScheme name="Simple Light">
       <a:dk1>
         <a:srgbClr val="000000"/>
       </a:dk1>
@@ -54744,34 +54744,34 @@
         <a:srgbClr val="FFFFFF"/>
       </a:lt1>
       <a:dk2>
-        <a:srgbClr val="158158"/>
+        <a:srgbClr val="595959"/>
       </a:dk2>
       <a:lt2>
-        <a:srgbClr val="F3F3F3"/>
+        <a:srgbClr val="EEEEEE"/>
       </a:lt2>
       <a:accent1>
-        <a:srgbClr val="058DC7"/>
+        <a:srgbClr val="4285F4"/>
       </a:accent1>
       <a:accent2>
-        <a:srgbClr val="50B432"/>
+        <a:srgbClr val="212121"/>
       </a:accent2>
       <a:accent3>
-        <a:srgbClr val="ED561B"/>
+        <a:srgbClr val="78909C"/>
       </a:accent3>
       <a:accent4>
-        <a:srgbClr val="EDEF00"/>
+        <a:srgbClr val="FFAB40"/>
       </a:accent4>
       <a:accent5>
-        <a:srgbClr val="24CBE5"/>
+        <a:srgbClr val="0097A7"/>
       </a:accent5>
       <a:accent6>
-        <a:srgbClr val="64E572"/>
+        <a:srgbClr val="EEFF41"/>
       </a:accent6>
       <a:hlink>
-        <a:srgbClr val="2200CC"/>
+        <a:srgbClr val="0097A7"/>
       </a:hlink>
       <a:folHlink>
-        <a:srgbClr val="551A8B"/>
+        <a:srgbClr val="0097A7"/>
       </a:folHlink>
     </a:clrScheme>
     <a:fontScheme name="Office">
@@ -55013,9 +55013,9 @@
 </file>
 
 <file path=ppt/theme/theme2.xml><?xml version="1.0" encoding="utf-8"?>
-<a:theme xmlns:a="http://schemas.openxmlformats.org/drawingml/2006/main" xmlns:r="http://schemas.openxmlformats.org/officeDocument/2006/relationships" name="Office Theme">
+<a:theme xmlns:a="http://schemas.openxmlformats.org/drawingml/2006/main" xmlns:r="http://schemas.openxmlformats.org/officeDocument/2006/relationships" name="Simple Light">
   <a:themeElements>
-    <a:clrScheme name="Office">
+    <a:clrScheme name="Simple Light">
       <a:dk1>
         <a:srgbClr val="000000"/>
       </a:dk1>
@@ -55023,34 +55023,34 @@
         <a:srgbClr val="FFFFFF"/>
       </a:lt1>
       <a:dk2>
-        <a:srgbClr val="44546A"/>
+        <a:srgbClr val="595959"/>
       </a:dk2>
       <a:lt2>
-        <a:srgbClr val="E7E6E6"/>
+        <a:srgbClr val="EEEEEE"/>
       </a:lt2>
       <a:accent1>
-        <a:srgbClr val="4472C4"/>
+        <a:srgbClr val="4285F4"/>
       </a:accent1>
       <a:accent2>
-        <a:srgbClr val="ED7D31"/>
+        <a:srgbClr val="212121"/>
       </a:accent2>
       <a:accent3>
-        <a:srgbClr val="A5A5A5"/>
+        <a:srgbClr val="78909C"/>
       </a:accent3>
       <a:accent4>
-        <a:srgbClr val="FFC000"/>
+        <a:srgbClr val="FFAB40"/>
       </a:accent4>
       <a:accent5>
-        <a:srgbClr val="5B9BD5"/>
+        <a:srgbClr val="0097A7"/>
       </a:accent5>
       <a:accent6>
-        <a:srgbClr val="70AD47"/>
+        <a:srgbClr val="EEFF41"/>
       </a:accent6>
       <a:hlink>
-        <a:srgbClr val="0563C1"/>
+        <a:srgbClr val="0097A7"/>
       </a:hlink>
       <a:folHlink>
-        <a:srgbClr val="954F72"/>
+        <a:srgbClr val="0097A7"/>
       </a:folHlink>
     </a:clrScheme>
     <a:fontScheme name="Office">
@@ -55571,9 +55571,9 @@
 </file>
 
 <file path=ppt/theme/theme4.xml><?xml version="1.0" encoding="utf-8"?>
-<a:theme xmlns:a="http://schemas.openxmlformats.org/drawingml/2006/main" xmlns:r="http://schemas.openxmlformats.org/officeDocument/2006/relationships" name="Simple Light">
+<a:theme xmlns:a="http://schemas.openxmlformats.org/drawingml/2006/main" xmlns:r="http://schemas.openxmlformats.org/officeDocument/2006/relationships">
   <a:themeElements>
-    <a:clrScheme name="Simple Light">
+    <a:clrScheme name="Default">
       <a:dk1>
         <a:srgbClr val="000000"/>
       </a:dk1>
@@ -55581,34 +55581,34 @@
         <a:srgbClr val="FFFFFF"/>
       </a:lt1>
       <a:dk2>
-        <a:srgbClr val="595959"/>
+        <a:srgbClr val="158158"/>
       </a:dk2>
       <a:lt2>
-        <a:srgbClr val="EEEEEE"/>
+        <a:srgbClr val="F3F3F3"/>
       </a:lt2>
       <a:accent1>
-        <a:srgbClr val="4285F4"/>
+        <a:srgbClr val="058DC7"/>
       </a:accent1>
       <a:accent2>
-        <a:srgbClr val="212121"/>
+        <a:srgbClr val="50B432"/>
       </a:accent2>
       <a:accent3>
-        <a:srgbClr val="78909C"/>
+        <a:srgbClr val="ED561B"/>
       </a:accent3>
       <a:accent4>
-        <a:srgbClr val="FFAB40"/>
+        <a:srgbClr val="EDEF00"/>
       </a:accent4>
       <a:accent5>
-        <a:srgbClr val="0097A7"/>
+        <a:srgbClr val="24CBE5"/>
       </a:accent5>
       <a:accent6>
-        <a:srgbClr val="EEFF41"/>
+        <a:srgbClr val="64E572"/>
       </a:accent6>
       <a:hlink>
-        <a:srgbClr val="0097A7"/>
+        <a:srgbClr val="2200CC"/>
       </a:hlink>
       <a:folHlink>
-        <a:srgbClr val="0097A7"/>
+        <a:srgbClr val="551A8B"/>
       </a:folHlink>
     </a:clrScheme>
     <a:fontScheme name="Office">
@@ -55850,9 +55850,9 @@
 </file>
 
 <file path=ppt/theme/theme5.xml><?xml version="1.0" encoding="utf-8"?>
-<a:theme xmlns:a="http://schemas.openxmlformats.org/drawingml/2006/main" xmlns:r="http://schemas.openxmlformats.org/officeDocument/2006/relationships" name="Simple Light">
+<a:theme xmlns:a="http://schemas.openxmlformats.org/drawingml/2006/main" xmlns:r="http://schemas.openxmlformats.org/officeDocument/2006/relationships" name="Office Theme">
   <a:themeElements>
-    <a:clrScheme name="Simple Light">
+    <a:clrScheme name="Office">
       <a:dk1>
         <a:srgbClr val="000000"/>
       </a:dk1>
@@ -55860,34 +55860,34 @@
         <a:srgbClr val="FFFFFF"/>
       </a:lt1>
       <a:dk2>
-        <a:srgbClr val="595959"/>
+        <a:srgbClr val="44546A"/>
       </a:dk2>
       <a:lt2>
-        <a:srgbClr val="EEEEEE"/>
+        <a:srgbClr val="E7E6E6"/>
       </a:lt2>
       <a:accent1>
-        <a:srgbClr val="4285F4"/>
+        <a:srgbClr val="4472C4"/>
       </a:accent1>
       <a:accent2>
-        <a:srgbClr val="212121"/>
+        <a:srgbClr val="ED7D31"/>
       </a:accent2>
       <a:accent3>
-        <a:srgbClr val="78909C"/>
+        <a:srgbClr val="A5A5A5"/>
       </a:accent3>
       <a:accent4>
-        <a:srgbClr val="FFAB40"/>
+        <a:srgbClr val="FFC000"/>
       </a:accent4>
       <a:accent5>
-        <a:srgbClr val="0097A7"/>
+        <a:srgbClr val="5B9BD5"/>
       </a:accent5>
       <a:accent6>
-        <a:srgbClr val="EEFF41"/>
+        <a:srgbClr val="70AD47"/>
       </a:accent6>
       <a:hlink>
-        <a:srgbClr val="0097A7"/>
+        <a:srgbClr val="0563C1"/>
       </a:hlink>
       <a:folHlink>
-        <a:srgbClr val="0097A7"/>
+        <a:srgbClr val="954F72"/>
       </a:folHlink>
     </a:clrScheme>
     <a:fontScheme name="Office">

</xml_diff>

<commit_message>
Pull Drive-newer notebooks, deck and setup docx (drift reconciliation before 2026-09 refresh)
Co-Authored-By: Claude Fable 5.1 <noreply@anthropic.com>
Claude-Session: https://claude.ai/code/session_013ZyZmXoJVnzkDMWgzrVGff
</commit_message>
<xml_diff>
--- a/0_genAI_in_Python.pptx
+++ b/0_genAI_in_Python.pptx
@@ -70,7 +70,7 @@
         <a:srgbClr val="000000"/>
       </a:buClr>
       <a:buFont typeface="Arial"/>
-      <a:defRPr b="0" i="0" sz="1400" u="none" cap="none" strike="noStrike">
+      <a:defRPr b="0" i="0" spc="0" sz="1400" u="none" cap="none" strike="noStrike">
         <a:solidFill>
           <a:srgbClr val="000000"/>
         </a:solidFill>
@@ -94,7 +94,7 @@
         <a:srgbClr val="000000"/>
       </a:buClr>
       <a:buFont typeface="Arial"/>
-      <a:defRPr b="0" i="0" sz="1400" u="none" cap="none" strike="noStrike">
+      <a:defRPr b="0" i="0" spc="0" sz="1400" u="none" cap="none" strike="noStrike">
         <a:solidFill>
           <a:srgbClr val="000000"/>
         </a:solidFill>
@@ -118,7 +118,7 @@
         <a:srgbClr val="000000"/>
       </a:buClr>
       <a:buFont typeface="Arial"/>
-      <a:defRPr b="0" i="0" sz="1400" u="none" cap="none" strike="noStrike">
+      <a:defRPr b="0" i="0" spc="0" sz="1400" u="none" cap="none" strike="noStrike">
         <a:solidFill>
           <a:srgbClr val="000000"/>
         </a:solidFill>
@@ -142,7 +142,7 @@
         <a:srgbClr val="000000"/>
       </a:buClr>
       <a:buFont typeface="Arial"/>
-      <a:defRPr b="0" i="0" sz="1400" u="none" cap="none" strike="noStrike">
+      <a:defRPr b="0" i="0" spc="0" sz="1400" u="none" cap="none" strike="noStrike">
         <a:solidFill>
           <a:srgbClr val="000000"/>
         </a:solidFill>
@@ -166,7 +166,7 @@
         <a:srgbClr val="000000"/>
       </a:buClr>
       <a:buFont typeface="Arial"/>
-      <a:defRPr b="0" i="0" sz="1400" u="none" cap="none" strike="noStrike">
+      <a:defRPr b="0" i="0" spc="0" sz="1400" u="none" cap="none" strike="noStrike">
         <a:solidFill>
           <a:srgbClr val="000000"/>
         </a:solidFill>
@@ -190,7 +190,7 @@
         <a:srgbClr val="000000"/>
       </a:buClr>
       <a:buFont typeface="Arial"/>
-      <a:defRPr b="0" i="0" sz="1400" u="none" cap="none" strike="noStrike">
+      <a:defRPr b="0" i="0" spc="0" sz="1400" u="none" cap="none" strike="noStrike">
         <a:solidFill>
           <a:srgbClr val="000000"/>
         </a:solidFill>
@@ -214,7 +214,7 @@
         <a:srgbClr val="000000"/>
       </a:buClr>
       <a:buFont typeface="Arial"/>
-      <a:defRPr b="0" i="0" sz="1400" u="none" cap="none" strike="noStrike">
+      <a:defRPr b="0" i="0" spc="0" sz="1400" u="none" cap="none" strike="noStrike">
         <a:solidFill>
           <a:srgbClr val="000000"/>
         </a:solidFill>
@@ -238,7 +238,7 @@
         <a:srgbClr val="000000"/>
       </a:buClr>
       <a:buFont typeface="Arial"/>
-      <a:defRPr b="0" i="0" sz="1400" u="none" cap="none" strike="noStrike">
+      <a:defRPr b="0" i="0" spc="0" sz="1400" u="none" cap="none" strike="noStrike">
         <a:solidFill>
           <a:srgbClr val="000000"/>
         </a:solidFill>
@@ -262,7 +262,7 @@
         <a:srgbClr val="000000"/>
       </a:buClr>
       <a:buFont typeface="Arial"/>
-      <a:defRPr b="0" i="0" sz="1400" u="none" cap="none" strike="noStrike">
+      <a:defRPr b="0" i="0" spc="0" sz="1400" u="none" cap="none" strike="noStrike">
         <a:solidFill>
           <a:srgbClr val="000000"/>
         </a:solidFill>
@@ -650,7 +650,7 @@
         <a:srgbClr val="000000"/>
       </a:buClr>
       <a:buFont typeface="Arial"/>
-      <a:defRPr b="0" i="0" sz="1400" u="none" cap="none" strike="noStrike">
+      <a:defRPr b="0" i="0" spc="0" sz="1400" u="none" cap="none" strike="noStrike">
         <a:solidFill>
           <a:srgbClr val="000000"/>
         </a:solidFill>
@@ -674,7 +674,7 @@
         <a:srgbClr val="000000"/>
       </a:buClr>
       <a:buFont typeface="Arial"/>
-      <a:defRPr b="0" i="0" sz="1400" u="none" cap="none" strike="noStrike">
+      <a:defRPr b="0" i="0" spc="0" sz="1400" u="none" cap="none" strike="noStrike">
         <a:solidFill>
           <a:srgbClr val="000000"/>
         </a:solidFill>
@@ -698,7 +698,7 @@
         <a:srgbClr val="000000"/>
       </a:buClr>
       <a:buFont typeface="Arial"/>
-      <a:defRPr b="0" i="0" sz="1400" u="none" cap="none" strike="noStrike">
+      <a:defRPr b="0" i="0" spc="0" sz="1400" u="none" cap="none" strike="noStrike">
         <a:solidFill>
           <a:srgbClr val="000000"/>
         </a:solidFill>
@@ -722,7 +722,7 @@
         <a:srgbClr val="000000"/>
       </a:buClr>
       <a:buFont typeface="Arial"/>
-      <a:defRPr b="0" i="0" sz="1400" u="none" cap="none" strike="noStrike">
+      <a:defRPr b="0" i="0" spc="0" sz="1400" u="none" cap="none" strike="noStrike">
         <a:solidFill>
           <a:srgbClr val="000000"/>
         </a:solidFill>
@@ -746,7 +746,7 @@
         <a:srgbClr val="000000"/>
       </a:buClr>
       <a:buFont typeface="Arial"/>
-      <a:defRPr b="0" i="0" sz="1400" u="none" cap="none" strike="noStrike">
+      <a:defRPr b="0" i="0" spc="0" sz="1400" u="none" cap="none" strike="noStrike">
         <a:solidFill>
           <a:srgbClr val="000000"/>
         </a:solidFill>
@@ -770,7 +770,7 @@
         <a:srgbClr val="000000"/>
       </a:buClr>
       <a:buFont typeface="Arial"/>
-      <a:defRPr b="0" i="0" sz="1400" u="none" cap="none" strike="noStrike">
+      <a:defRPr b="0" i="0" spc="0" sz="1400" u="none" cap="none" strike="noStrike">
         <a:solidFill>
           <a:srgbClr val="000000"/>
         </a:solidFill>
@@ -794,7 +794,7 @@
         <a:srgbClr val="000000"/>
       </a:buClr>
       <a:buFont typeface="Arial"/>
-      <a:defRPr b="0" i="0" sz="1400" u="none" cap="none" strike="noStrike">
+      <a:defRPr b="0" i="0" spc="0" sz="1400" u="none" cap="none" strike="noStrike">
         <a:solidFill>
           <a:srgbClr val="000000"/>
         </a:solidFill>
@@ -818,7 +818,7 @@
         <a:srgbClr val="000000"/>
       </a:buClr>
       <a:buFont typeface="Arial"/>
-      <a:defRPr b="0" i="0" sz="1400" u="none" cap="none" strike="noStrike">
+      <a:defRPr b="0" i="0" spc="0" sz="1400" u="none" cap="none" strike="noStrike">
         <a:solidFill>
           <a:srgbClr val="000000"/>
         </a:solidFill>
@@ -842,7 +842,7 @@
         <a:srgbClr val="000000"/>
       </a:buClr>
       <a:buFont typeface="Arial"/>
-      <a:defRPr b="0" i="0" sz="1400" u="none" cap="none" strike="noStrike">
+      <a:defRPr b="0" i="0" spc="0" sz="1400" u="none" cap="none" strike="noStrike">
         <a:solidFill>
           <a:srgbClr val="000000"/>
         </a:solidFill>
@@ -24245,7 +24245,7 @@
           <a:srgbClr val="000000"/>
         </a:buClr>
         <a:buFont typeface="Arial"/>
-        <a:defRPr b="0" i="0" sz="1400" u="none" cap="none" strike="noStrike">
+        <a:defRPr b="0" i="0" spc="0" sz="1400" u="none" cap="none" strike="noStrike">
           <a:solidFill>
             <a:srgbClr val="000000"/>
           </a:solidFill>
@@ -24269,7 +24269,7 @@
           <a:srgbClr val="000000"/>
         </a:buClr>
         <a:buFont typeface="Arial"/>
-        <a:defRPr b="0" i="0" sz="1400" u="none" cap="none" strike="noStrike">
+        <a:defRPr b="0" i="0" spc="0" sz="1400" u="none" cap="none" strike="noStrike">
           <a:solidFill>
             <a:srgbClr val="000000"/>
           </a:solidFill>
@@ -24293,7 +24293,7 @@
           <a:srgbClr val="000000"/>
         </a:buClr>
         <a:buFont typeface="Arial"/>
-        <a:defRPr b="0" i="0" sz="1400" u="none" cap="none" strike="noStrike">
+        <a:defRPr b="0" i="0" spc="0" sz="1400" u="none" cap="none" strike="noStrike">
           <a:solidFill>
             <a:srgbClr val="000000"/>
           </a:solidFill>
@@ -24317,7 +24317,7 @@
           <a:srgbClr val="000000"/>
         </a:buClr>
         <a:buFont typeface="Arial"/>
-        <a:defRPr b="0" i="0" sz="1400" u="none" cap="none" strike="noStrike">
+        <a:defRPr b="0" i="0" spc="0" sz="1400" u="none" cap="none" strike="noStrike">
           <a:solidFill>
             <a:srgbClr val="000000"/>
           </a:solidFill>
@@ -24341,7 +24341,7 @@
           <a:srgbClr val="000000"/>
         </a:buClr>
         <a:buFont typeface="Arial"/>
-        <a:defRPr b="0" i="0" sz="1400" u="none" cap="none" strike="noStrike">
+        <a:defRPr b="0" i="0" spc="0" sz="1400" u="none" cap="none" strike="noStrike">
           <a:solidFill>
             <a:srgbClr val="000000"/>
           </a:solidFill>
@@ -24365,7 +24365,7 @@
           <a:srgbClr val="000000"/>
         </a:buClr>
         <a:buFont typeface="Arial"/>
-        <a:defRPr b="0" i="0" sz="1400" u="none" cap="none" strike="noStrike">
+        <a:defRPr b="0" i="0" spc="0" sz="1400" u="none" cap="none" strike="noStrike">
           <a:solidFill>
             <a:srgbClr val="000000"/>
           </a:solidFill>
@@ -24389,7 +24389,7 @@
           <a:srgbClr val="000000"/>
         </a:buClr>
         <a:buFont typeface="Arial"/>
-        <a:defRPr b="0" i="0" sz="1400" u="none" cap="none" strike="noStrike">
+        <a:defRPr b="0" i="0" spc="0" sz="1400" u="none" cap="none" strike="noStrike">
           <a:solidFill>
             <a:srgbClr val="000000"/>
           </a:solidFill>
@@ -24413,7 +24413,7 @@
           <a:srgbClr val="000000"/>
         </a:buClr>
         <a:buFont typeface="Arial"/>
-        <a:defRPr b="0" i="0" sz="1400" u="none" cap="none" strike="noStrike">
+        <a:defRPr b="0" i="0" spc="0" sz="1400" u="none" cap="none" strike="noStrike">
           <a:solidFill>
             <a:srgbClr val="000000"/>
           </a:solidFill>
@@ -24437,7 +24437,7 @@
           <a:srgbClr val="000000"/>
         </a:buClr>
         <a:buFont typeface="Arial"/>
-        <a:defRPr b="0" i="0" sz="1400" u="none" cap="none" strike="noStrike">
+        <a:defRPr b="0" i="0" spc="0" sz="1400" u="none" cap="none" strike="noStrike">
           <a:solidFill>
             <a:srgbClr val="000000"/>
           </a:solidFill>
@@ -24474,7 +24474,7 @@
           <a:srgbClr val="000000"/>
         </a:buClr>
         <a:buFont typeface="Arial"/>
-        <a:defRPr b="0" i="0" sz="1400" u="none" cap="none" strike="noStrike">
+        <a:defRPr b="0" i="0" spc="0" sz="1400" u="none" cap="none" strike="noStrike">
           <a:solidFill>
             <a:srgbClr val="000000"/>
           </a:solidFill>
@@ -24498,7 +24498,7 @@
           <a:srgbClr val="000000"/>
         </a:buClr>
         <a:buFont typeface="Arial"/>
-        <a:defRPr b="0" i="0" sz="1400" u="none" cap="none" strike="noStrike">
+        <a:defRPr b="0" i="0" spc="0" sz="1400" u="none" cap="none" strike="noStrike">
           <a:solidFill>
             <a:srgbClr val="000000"/>
           </a:solidFill>
@@ -24522,7 +24522,7 @@
           <a:srgbClr val="000000"/>
         </a:buClr>
         <a:buFont typeface="Arial"/>
-        <a:defRPr b="0" i="0" sz="1400" u="none" cap="none" strike="noStrike">
+        <a:defRPr b="0" i="0" spc="0" sz="1400" u="none" cap="none" strike="noStrike">
           <a:solidFill>
             <a:srgbClr val="000000"/>
           </a:solidFill>
@@ -24546,7 +24546,7 @@
           <a:srgbClr val="000000"/>
         </a:buClr>
         <a:buFont typeface="Arial"/>
-        <a:defRPr b="0" i="0" sz="1400" u="none" cap="none" strike="noStrike">
+        <a:defRPr b="0" i="0" spc="0" sz="1400" u="none" cap="none" strike="noStrike">
           <a:solidFill>
             <a:srgbClr val="000000"/>
           </a:solidFill>
@@ -24570,7 +24570,7 @@
           <a:srgbClr val="000000"/>
         </a:buClr>
         <a:buFont typeface="Arial"/>
-        <a:defRPr b="0" i="0" sz="1400" u="none" cap="none" strike="noStrike">
+        <a:defRPr b="0" i="0" spc="0" sz="1400" u="none" cap="none" strike="noStrike">
           <a:solidFill>
             <a:srgbClr val="000000"/>
           </a:solidFill>
@@ -24594,7 +24594,7 @@
           <a:srgbClr val="000000"/>
         </a:buClr>
         <a:buFont typeface="Arial"/>
-        <a:defRPr b="0" i="0" sz="1400" u="none" cap="none" strike="noStrike">
+        <a:defRPr b="0" i="0" spc="0" sz="1400" u="none" cap="none" strike="noStrike">
           <a:solidFill>
             <a:srgbClr val="000000"/>
           </a:solidFill>
@@ -24618,7 +24618,7 @@
           <a:srgbClr val="000000"/>
         </a:buClr>
         <a:buFont typeface="Arial"/>
-        <a:defRPr b="0" i="0" sz="1400" u="none" cap="none" strike="noStrike">
+        <a:defRPr b="0" i="0" spc="0" sz="1400" u="none" cap="none" strike="noStrike">
           <a:solidFill>
             <a:srgbClr val="000000"/>
           </a:solidFill>
@@ -24642,7 +24642,7 @@
           <a:srgbClr val="000000"/>
         </a:buClr>
         <a:buFont typeface="Arial"/>
-        <a:defRPr b="0" i="0" sz="1400" u="none" cap="none" strike="noStrike">
+        <a:defRPr b="0" i="0" spc="0" sz="1400" u="none" cap="none" strike="noStrike">
           <a:solidFill>
             <a:srgbClr val="000000"/>
           </a:solidFill>
@@ -24666,7 +24666,7 @@
           <a:srgbClr val="000000"/>
         </a:buClr>
         <a:buFont typeface="Arial"/>
-        <a:defRPr b="0" i="0" sz="1400" u="none" cap="none" strike="noStrike">
+        <a:defRPr b="0" i="0" spc="0" sz="1400" u="none" cap="none" strike="noStrike">
           <a:solidFill>
             <a:srgbClr val="000000"/>
           </a:solidFill>
@@ -24703,7 +24703,7 @@
           <a:srgbClr val="000000"/>
         </a:buClr>
         <a:buFont typeface="Arial"/>
-        <a:defRPr b="0" i="0" sz="1400" u="none" cap="none" strike="noStrike">
+        <a:defRPr b="0" i="0" spc="0" sz="1400" u="none" cap="none" strike="noStrike">
           <a:solidFill>
             <a:srgbClr val="000000"/>
           </a:solidFill>
@@ -24727,7 +24727,7 @@
           <a:srgbClr val="000000"/>
         </a:buClr>
         <a:buFont typeface="Arial"/>
-        <a:defRPr b="0" i="0" sz="1400" u="none" cap="none" strike="noStrike">
+        <a:defRPr b="0" i="0" spc="0" sz="1400" u="none" cap="none" strike="noStrike">
           <a:solidFill>
             <a:srgbClr val="000000"/>
           </a:solidFill>
@@ -24751,7 +24751,7 @@
           <a:srgbClr val="000000"/>
         </a:buClr>
         <a:buFont typeface="Arial"/>
-        <a:defRPr b="0" i="0" sz="1400" u="none" cap="none" strike="noStrike">
+        <a:defRPr b="0" i="0" spc="0" sz="1400" u="none" cap="none" strike="noStrike">
           <a:solidFill>
             <a:srgbClr val="000000"/>
           </a:solidFill>
@@ -24775,7 +24775,7 @@
           <a:srgbClr val="000000"/>
         </a:buClr>
         <a:buFont typeface="Arial"/>
-        <a:defRPr b="0" i="0" sz="1400" u="none" cap="none" strike="noStrike">
+        <a:defRPr b="0" i="0" spc="0" sz="1400" u="none" cap="none" strike="noStrike">
           <a:solidFill>
             <a:srgbClr val="000000"/>
           </a:solidFill>
@@ -24799,7 +24799,7 @@
           <a:srgbClr val="000000"/>
         </a:buClr>
         <a:buFont typeface="Arial"/>
-        <a:defRPr b="0" i="0" sz="1400" u="none" cap="none" strike="noStrike">
+        <a:defRPr b="0" i="0" spc="0" sz="1400" u="none" cap="none" strike="noStrike">
           <a:solidFill>
             <a:srgbClr val="000000"/>
           </a:solidFill>
@@ -24823,7 +24823,7 @@
           <a:srgbClr val="000000"/>
         </a:buClr>
         <a:buFont typeface="Arial"/>
-        <a:defRPr b="0" i="0" sz="1400" u="none" cap="none" strike="noStrike">
+        <a:defRPr b="0" i="0" spc="0" sz="1400" u="none" cap="none" strike="noStrike">
           <a:solidFill>
             <a:srgbClr val="000000"/>
           </a:solidFill>
@@ -24847,7 +24847,7 @@
           <a:srgbClr val="000000"/>
         </a:buClr>
         <a:buFont typeface="Arial"/>
-        <a:defRPr b="0" i="0" sz="1400" u="none" cap="none" strike="noStrike">
+        <a:defRPr b="0" i="0" spc="0" sz="1400" u="none" cap="none" strike="noStrike">
           <a:solidFill>
             <a:srgbClr val="000000"/>
           </a:solidFill>
@@ -24871,7 +24871,7 @@
           <a:srgbClr val="000000"/>
         </a:buClr>
         <a:buFont typeface="Arial"/>
-        <a:defRPr b="0" i="0" sz="1400" u="none" cap="none" strike="noStrike">
+        <a:defRPr b="0" i="0" spc="0" sz="1400" u="none" cap="none" strike="noStrike">
           <a:solidFill>
             <a:srgbClr val="000000"/>
           </a:solidFill>
@@ -24895,7 +24895,7 @@
           <a:srgbClr val="000000"/>
         </a:buClr>
         <a:buFont typeface="Arial"/>
-        <a:defRPr b="0" i="0" sz="1400" u="none" cap="none" strike="noStrike">
+        <a:defRPr b="0" i="0" spc="0" sz="1400" u="none" cap="none" strike="noStrike">
           <a:solidFill>
             <a:srgbClr val="000000"/>
           </a:solidFill>
@@ -24961,7 +24961,7 @@
           <a:srgbClr val="000000"/>
         </a:buClr>
         <a:buFont typeface="Arial"/>
-        <a:defRPr b="0" i="0" sz="1400" u="none" cap="none" strike="noStrike">
+        <a:defRPr b="0" i="0" spc="0" sz="1400" u="none" cap="none" strike="noStrike">
           <a:solidFill>
             <a:srgbClr val="000000"/>
           </a:solidFill>
@@ -24985,7 +24985,7 @@
           <a:srgbClr val="000000"/>
         </a:buClr>
         <a:buFont typeface="Arial"/>
-        <a:defRPr b="0" i="0" sz="1400" u="none" cap="none" strike="noStrike">
+        <a:defRPr b="0" i="0" spc="0" sz="1400" u="none" cap="none" strike="noStrike">
           <a:solidFill>
             <a:srgbClr val="000000"/>
           </a:solidFill>
@@ -25009,7 +25009,7 @@
           <a:srgbClr val="000000"/>
         </a:buClr>
         <a:buFont typeface="Arial"/>
-        <a:defRPr b="0" i="0" sz="1400" u="none" cap="none" strike="noStrike">
+        <a:defRPr b="0" i="0" spc="0" sz="1400" u="none" cap="none" strike="noStrike">
           <a:solidFill>
             <a:srgbClr val="000000"/>
           </a:solidFill>
@@ -25033,7 +25033,7 @@
           <a:srgbClr val="000000"/>
         </a:buClr>
         <a:buFont typeface="Arial"/>
-        <a:defRPr b="0" i="0" sz="1400" u="none" cap="none" strike="noStrike">
+        <a:defRPr b="0" i="0" spc="0" sz="1400" u="none" cap="none" strike="noStrike">
           <a:solidFill>
             <a:srgbClr val="000000"/>
           </a:solidFill>
@@ -25057,7 +25057,7 @@
           <a:srgbClr val="000000"/>
         </a:buClr>
         <a:buFont typeface="Arial"/>
-        <a:defRPr b="0" i="0" sz="1400" u="none" cap="none" strike="noStrike">
+        <a:defRPr b="0" i="0" spc="0" sz="1400" u="none" cap="none" strike="noStrike">
           <a:solidFill>
             <a:srgbClr val="000000"/>
           </a:solidFill>
@@ -25081,7 +25081,7 @@
           <a:srgbClr val="000000"/>
         </a:buClr>
         <a:buFont typeface="Arial"/>
-        <a:defRPr b="0" i="0" sz="1400" u="none" cap="none" strike="noStrike">
+        <a:defRPr b="0" i="0" spc="0" sz="1400" u="none" cap="none" strike="noStrike">
           <a:solidFill>
             <a:srgbClr val="000000"/>
           </a:solidFill>
@@ -25105,7 +25105,7 @@
           <a:srgbClr val="000000"/>
         </a:buClr>
         <a:buFont typeface="Arial"/>
-        <a:defRPr b="0" i="0" sz="1400" u="none" cap="none" strike="noStrike">
+        <a:defRPr b="0" i="0" spc="0" sz="1400" u="none" cap="none" strike="noStrike">
           <a:solidFill>
             <a:srgbClr val="000000"/>
           </a:solidFill>
@@ -25129,7 +25129,7 @@
           <a:srgbClr val="000000"/>
         </a:buClr>
         <a:buFont typeface="Arial"/>
-        <a:defRPr b="0" i="0" sz="1400" u="none" cap="none" strike="noStrike">
+        <a:defRPr b="0" i="0" spc="0" sz="1400" u="none" cap="none" strike="noStrike">
           <a:solidFill>
             <a:srgbClr val="000000"/>
           </a:solidFill>
@@ -25153,7 +25153,7 @@
           <a:srgbClr val="000000"/>
         </a:buClr>
         <a:buFont typeface="Arial"/>
-        <a:defRPr b="0" i="0" sz="1400" u="none" cap="none" strike="noStrike">
+        <a:defRPr b="0" i="0" spc="0" sz="1400" u="none" cap="none" strike="noStrike">
           <a:solidFill>
             <a:srgbClr val="000000"/>
           </a:solidFill>
@@ -25190,7 +25190,7 @@
           <a:srgbClr val="000000"/>
         </a:buClr>
         <a:buFont typeface="Arial"/>
-        <a:defRPr b="0" i="0" sz="1400" u="none" cap="none" strike="noStrike">
+        <a:defRPr b="0" i="0" spc="0" sz="1400" u="none" cap="none" strike="noStrike">
           <a:solidFill>
             <a:srgbClr val="000000"/>
           </a:solidFill>
@@ -25214,7 +25214,7 @@
           <a:srgbClr val="000000"/>
         </a:buClr>
         <a:buFont typeface="Arial"/>
-        <a:defRPr b="0" i="0" sz="1400" u="none" cap="none" strike="noStrike">
+        <a:defRPr b="0" i="0" spc="0" sz="1400" u="none" cap="none" strike="noStrike">
           <a:solidFill>
             <a:srgbClr val="000000"/>
           </a:solidFill>
@@ -25238,7 +25238,7 @@
           <a:srgbClr val="000000"/>
         </a:buClr>
         <a:buFont typeface="Arial"/>
-        <a:defRPr b="0" i="0" sz="1400" u="none" cap="none" strike="noStrike">
+        <a:defRPr b="0" i="0" spc="0" sz="1400" u="none" cap="none" strike="noStrike">
           <a:solidFill>
             <a:srgbClr val="000000"/>
           </a:solidFill>
@@ -25262,7 +25262,7 @@
           <a:srgbClr val="000000"/>
         </a:buClr>
         <a:buFont typeface="Arial"/>
-        <a:defRPr b="0" i="0" sz="1400" u="none" cap="none" strike="noStrike">
+        <a:defRPr b="0" i="0" spc="0" sz="1400" u="none" cap="none" strike="noStrike">
           <a:solidFill>
             <a:srgbClr val="000000"/>
           </a:solidFill>
@@ -25286,7 +25286,7 @@
           <a:srgbClr val="000000"/>
         </a:buClr>
         <a:buFont typeface="Arial"/>
-        <a:defRPr b="0" i="0" sz="1400" u="none" cap="none" strike="noStrike">
+        <a:defRPr b="0" i="0" spc="0" sz="1400" u="none" cap="none" strike="noStrike">
           <a:solidFill>
             <a:srgbClr val="000000"/>
           </a:solidFill>
@@ -25310,7 +25310,7 @@
           <a:srgbClr val="000000"/>
         </a:buClr>
         <a:buFont typeface="Arial"/>
-        <a:defRPr b="0" i="0" sz="1400" u="none" cap="none" strike="noStrike">
+        <a:defRPr b="0" i="0" spc="0" sz="1400" u="none" cap="none" strike="noStrike">
           <a:solidFill>
             <a:srgbClr val="000000"/>
           </a:solidFill>
@@ -25334,7 +25334,7 @@
           <a:srgbClr val="000000"/>
         </a:buClr>
         <a:buFont typeface="Arial"/>
-        <a:defRPr b="0" i="0" sz="1400" u="none" cap="none" strike="noStrike">
+        <a:defRPr b="0" i="0" spc="0" sz="1400" u="none" cap="none" strike="noStrike">
           <a:solidFill>
             <a:srgbClr val="000000"/>
           </a:solidFill>
@@ -25358,7 +25358,7 @@
           <a:srgbClr val="000000"/>
         </a:buClr>
         <a:buFont typeface="Arial"/>
-        <a:defRPr b="0" i="0" sz="1400" u="none" cap="none" strike="noStrike">
+        <a:defRPr b="0" i="0" spc="0" sz="1400" u="none" cap="none" strike="noStrike">
           <a:solidFill>
             <a:srgbClr val="000000"/>
           </a:solidFill>
@@ -25382,7 +25382,7 @@
           <a:srgbClr val="000000"/>
         </a:buClr>
         <a:buFont typeface="Arial"/>
-        <a:defRPr b="0" i="0" sz="1400" u="none" cap="none" strike="noStrike">
+        <a:defRPr b="0" i="0" spc="0" sz="1400" u="none" cap="none" strike="noStrike">
           <a:solidFill>
             <a:srgbClr val="000000"/>
           </a:solidFill>
@@ -25419,7 +25419,7 @@
           <a:srgbClr val="000000"/>
         </a:buClr>
         <a:buFont typeface="Arial"/>
-        <a:defRPr b="0" i="0" sz="1400" u="none" cap="none" strike="noStrike">
+        <a:defRPr b="0" i="0" spc="0" sz="1400" u="none" cap="none" strike="noStrike">
           <a:solidFill>
             <a:srgbClr val="000000"/>
           </a:solidFill>
@@ -25443,7 +25443,7 @@
           <a:srgbClr val="000000"/>
         </a:buClr>
         <a:buFont typeface="Arial"/>
-        <a:defRPr b="0" i="0" sz="1400" u="none" cap="none" strike="noStrike">
+        <a:defRPr b="0" i="0" spc="0" sz="1400" u="none" cap="none" strike="noStrike">
           <a:solidFill>
             <a:srgbClr val="000000"/>
           </a:solidFill>
@@ -25467,7 +25467,7 @@
           <a:srgbClr val="000000"/>
         </a:buClr>
         <a:buFont typeface="Arial"/>
-        <a:defRPr b="0" i="0" sz="1400" u="none" cap="none" strike="noStrike">
+        <a:defRPr b="0" i="0" spc="0" sz="1400" u="none" cap="none" strike="noStrike">
           <a:solidFill>
             <a:srgbClr val="000000"/>
           </a:solidFill>
@@ -25491,7 +25491,7 @@
           <a:srgbClr val="000000"/>
         </a:buClr>
         <a:buFont typeface="Arial"/>
-        <a:defRPr b="0" i="0" sz="1400" u="none" cap="none" strike="noStrike">
+        <a:defRPr b="0" i="0" spc="0" sz="1400" u="none" cap="none" strike="noStrike">
           <a:solidFill>
             <a:srgbClr val="000000"/>
           </a:solidFill>
@@ -25515,7 +25515,7 @@
           <a:srgbClr val="000000"/>
         </a:buClr>
         <a:buFont typeface="Arial"/>
-        <a:defRPr b="0" i="0" sz="1400" u="none" cap="none" strike="noStrike">
+        <a:defRPr b="0" i="0" spc="0" sz="1400" u="none" cap="none" strike="noStrike">
           <a:solidFill>
             <a:srgbClr val="000000"/>
           </a:solidFill>
@@ -25539,7 +25539,7 @@
           <a:srgbClr val="000000"/>
         </a:buClr>
         <a:buFont typeface="Arial"/>
-        <a:defRPr b="0" i="0" sz="1400" u="none" cap="none" strike="noStrike">
+        <a:defRPr b="0" i="0" spc="0" sz="1400" u="none" cap="none" strike="noStrike">
           <a:solidFill>
             <a:srgbClr val="000000"/>
           </a:solidFill>
@@ -25563,7 +25563,7 @@
           <a:srgbClr val="000000"/>
         </a:buClr>
         <a:buFont typeface="Arial"/>
-        <a:defRPr b="0" i="0" sz="1400" u="none" cap="none" strike="noStrike">
+        <a:defRPr b="0" i="0" spc="0" sz="1400" u="none" cap="none" strike="noStrike">
           <a:solidFill>
             <a:srgbClr val="000000"/>
           </a:solidFill>
@@ -25587,7 +25587,7 @@
           <a:srgbClr val="000000"/>
         </a:buClr>
         <a:buFont typeface="Arial"/>
-        <a:defRPr b="0" i="0" sz="1400" u="none" cap="none" strike="noStrike">
+        <a:defRPr b="0" i="0" spc="0" sz="1400" u="none" cap="none" strike="noStrike">
           <a:solidFill>
             <a:srgbClr val="000000"/>
           </a:solidFill>
@@ -25611,7 +25611,7 @@
           <a:srgbClr val="000000"/>
         </a:buClr>
         <a:buFont typeface="Arial"/>
-        <a:defRPr b="0" i="0" sz="1400" u="none" cap="none" strike="noStrike">
+        <a:defRPr b="0" i="0" spc="0" sz="1400" u="none" cap="none" strike="noStrike">
           <a:solidFill>
             <a:srgbClr val="000000"/>
           </a:solidFill>
@@ -26504,7 +26504,7 @@
           <a:srgbClr val="000000"/>
         </a:buClr>
         <a:buFont typeface="Arial"/>
-        <a:defRPr b="0" i="0" sz="1400" u="none" cap="none" strike="noStrike">
+        <a:defRPr b="0" i="0" spc="0" sz="1400" u="none" cap="none" strike="noStrike">
           <a:solidFill>
             <a:srgbClr val="000000"/>
           </a:solidFill>
@@ -26528,7 +26528,7 @@
           <a:srgbClr val="000000"/>
         </a:buClr>
         <a:buFont typeface="Arial"/>
-        <a:defRPr b="0" i="0" sz="1400" u="none" cap="none" strike="noStrike">
+        <a:defRPr b="0" i="0" spc="0" sz="1400" u="none" cap="none" strike="noStrike">
           <a:solidFill>
             <a:srgbClr val="000000"/>
           </a:solidFill>
@@ -26552,7 +26552,7 @@
           <a:srgbClr val="000000"/>
         </a:buClr>
         <a:buFont typeface="Arial"/>
-        <a:defRPr b="0" i="0" sz="1400" u="none" cap="none" strike="noStrike">
+        <a:defRPr b="0" i="0" spc="0" sz="1400" u="none" cap="none" strike="noStrike">
           <a:solidFill>
             <a:srgbClr val="000000"/>
           </a:solidFill>
@@ -26576,7 +26576,7 @@
           <a:srgbClr val="000000"/>
         </a:buClr>
         <a:buFont typeface="Arial"/>
-        <a:defRPr b="0" i="0" sz="1400" u="none" cap="none" strike="noStrike">
+        <a:defRPr b="0" i="0" spc="0" sz="1400" u="none" cap="none" strike="noStrike">
           <a:solidFill>
             <a:srgbClr val="000000"/>
           </a:solidFill>
@@ -26600,7 +26600,7 @@
           <a:srgbClr val="000000"/>
         </a:buClr>
         <a:buFont typeface="Arial"/>
-        <a:defRPr b="0" i="0" sz="1400" u="none" cap="none" strike="noStrike">
+        <a:defRPr b="0" i="0" spc="0" sz="1400" u="none" cap="none" strike="noStrike">
           <a:solidFill>
             <a:srgbClr val="000000"/>
           </a:solidFill>
@@ -26624,7 +26624,7 @@
           <a:srgbClr val="000000"/>
         </a:buClr>
         <a:buFont typeface="Arial"/>
-        <a:defRPr b="0" i="0" sz="1400" u="none" cap="none" strike="noStrike">
+        <a:defRPr b="0" i="0" spc="0" sz="1400" u="none" cap="none" strike="noStrike">
           <a:solidFill>
             <a:srgbClr val="000000"/>
           </a:solidFill>
@@ -26648,7 +26648,7 @@
           <a:srgbClr val="000000"/>
         </a:buClr>
         <a:buFont typeface="Arial"/>
-        <a:defRPr b="0" i="0" sz="1400" u="none" cap="none" strike="noStrike">
+        <a:defRPr b="0" i="0" spc="0" sz="1400" u="none" cap="none" strike="noStrike">
           <a:solidFill>
             <a:srgbClr val="000000"/>
           </a:solidFill>
@@ -26672,7 +26672,7 @@
           <a:srgbClr val="000000"/>
         </a:buClr>
         <a:buFont typeface="Arial"/>
-        <a:defRPr b="0" i="0" sz="1400" u="none" cap="none" strike="noStrike">
+        <a:defRPr b="0" i="0" spc="0" sz="1400" u="none" cap="none" strike="noStrike">
           <a:solidFill>
             <a:srgbClr val="000000"/>
           </a:solidFill>
@@ -26696,7 +26696,7 @@
           <a:srgbClr val="000000"/>
         </a:buClr>
         <a:buFont typeface="Arial"/>
-        <a:defRPr b="0" i="0" sz="1400" u="none" cap="none" strike="noStrike">
+        <a:defRPr b="0" i="0" spc="0" sz="1400" u="none" cap="none" strike="noStrike">
           <a:solidFill>
             <a:srgbClr val="000000"/>
           </a:solidFill>
@@ -26733,7 +26733,7 @@
           <a:srgbClr val="000000"/>
         </a:buClr>
         <a:buFont typeface="Arial"/>
-        <a:defRPr b="0" i="0" sz="1400" u="none" cap="none" strike="noStrike">
+        <a:defRPr b="0" i="0" spc="0" sz="1400" u="none" cap="none" strike="noStrike">
           <a:solidFill>
             <a:srgbClr val="000000"/>
           </a:solidFill>
@@ -26757,7 +26757,7 @@
           <a:srgbClr val="000000"/>
         </a:buClr>
         <a:buFont typeface="Arial"/>
-        <a:defRPr b="0" i="0" sz="1400" u="none" cap="none" strike="noStrike">
+        <a:defRPr b="0" i="0" spc="0" sz="1400" u="none" cap="none" strike="noStrike">
           <a:solidFill>
             <a:srgbClr val="000000"/>
           </a:solidFill>
@@ -26781,7 +26781,7 @@
           <a:srgbClr val="000000"/>
         </a:buClr>
         <a:buFont typeface="Arial"/>
-        <a:defRPr b="0" i="0" sz="1400" u="none" cap="none" strike="noStrike">
+        <a:defRPr b="0" i="0" spc="0" sz="1400" u="none" cap="none" strike="noStrike">
           <a:solidFill>
             <a:srgbClr val="000000"/>
           </a:solidFill>
@@ -26805,7 +26805,7 @@
           <a:srgbClr val="000000"/>
         </a:buClr>
         <a:buFont typeface="Arial"/>
-        <a:defRPr b="0" i="0" sz="1400" u="none" cap="none" strike="noStrike">
+        <a:defRPr b="0" i="0" spc="0" sz="1400" u="none" cap="none" strike="noStrike">
           <a:solidFill>
             <a:srgbClr val="000000"/>
           </a:solidFill>
@@ -26829,7 +26829,7 @@
           <a:srgbClr val="000000"/>
         </a:buClr>
         <a:buFont typeface="Arial"/>
-        <a:defRPr b="0" i="0" sz="1400" u="none" cap="none" strike="noStrike">
+        <a:defRPr b="0" i="0" spc="0" sz="1400" u="none" cap="none" strike="noStrike">
           <a:solidFill>
             <a:srgbClr val="000000"/>
           </a:solidFill>
@@ -26853,7 +26853,7 @@
           <a:srgbClr val="000000"/>
         </a:buClr>
         <a:buFont typeface="Arial"/>
-        <a:defRPr b="0" i="0" sz="1400" u="none" cap="none" strike="noStrike">
+        <a:defRPr b="0" i="0" spc="0" sz="1400" u="none" cap="none" strike="noStrike">
           <a:solidFill>
             <a:srgbClr val="000000"/>
           </a:solidFill>
@@ -26877,7 +26877,7 @@
           <a:srgbClr val="000000"/>
         </a:buClr>
         <a:buFont typeface="Arial"/>
-        <a:defRPr b="0" i="0" sz="1400" u="none" cap="none" strike="noStrike">
+        <a:defRPr b="0" i="0" spc="0" sz="1400" u="none" cap="none" strike="noStrike">
           <a:solidFill>
             <a:srgbClr val="000000"/>
           </a:solidFill>
@@ -26901,7 +26901,7 @@
           <a:srgbClr val="000000"/>
         </a:buClr>
         <a:buFont typeface="Arial"/>
-        <a:defRPr b="0" i="0" sz="1400" u="none" cap="none" strike="noStrike">
+        <a:defRPr b="0" i="0" spc="0" sz="1400" u="none" cap="none" strike="noStrike">
           <a:solidFill>
             <a:srgbClr val="000000"/>
           </a:solidFill>
@@ -26925,7 +26925,7 @@
           <a:srgbClr val="000000"/>
         </a:buClr>
         <a:buFont typeface="Arial"/>
-        <a:defRPr b="0" i="0" sz="1400" u="none" cap="none" strike="noStrike">
+        <a:defRPr b="0" i="0" spc="0" sz="1400" u="none" cap="none" strike="noStrike">
           <a:solidFill>
             <a:srgbClr val="000000"/>
           </a:solidFill>
@@ -26962,7 +26962,7 @@
           <a:srgbClr val="000000"/>
         </a:buClr>
         <a:buFont typeface="Arial"/>
-        <a:defRPr b="0" i="0" sz="1400" u="none" cap="none" strike="noStrike">
+        <a:defRPr b="0" i="0" spc="0" sz="1400" u="none" cap="none" strike="noStrike">
           <a:solidFill>
             <a:srgbClr val="000000"/>
           </a:solidFill>
@@ -26986,7 +26986,7 @@
           <a:srgbClr val="000000"/>
         </a:buClr>
         <a:buFont typeface="Arial"/>
-        <a:defRPr b="0" i="0" sz="1400" u="none" cap="none" strike="noStrike">
+        <a:defRPr b="0" i="0" spc="0" sz="1400" u="none" cap="none" strike="noStrike">
           <a:solidFill>
             <a:srgbClr val="000000"/>
           </a:solidFill>
@@ -27010,7 +27010,7 @@
           <a:srgbClr val="000000"/>
         </a:buClr>
         <a:buFont typeface="Arial"/>
-        <a:defRPr b="0" i="0" sz="1400" u="none" cap="none" strike="noStrike">
+        <a:defRPr b="0" i="0" spc="0" sz="1400" u="none" cap="none" strike="noStrike">
           <a:solidFill>
             <a:srgbClr val="000000"/>
           </a:solidFill>
@@ -27034,7 +27034,7 @@
           <a:srgbClr val="000000"/>
         </a:buClr>
         <a:buFont typeface="Arial"/>
-        <a:defRPr b="0" i="0" sz="1400" u="none" cap="none" strike="noStrike">
+        <a:defRPr b="0" i="0" spc="0" sz="1400" u="none" cap="none" strike="noStrike">
           <a:solidFill>
             <a:srgbClr val="000000"/>
           </a:solidFill>
@@ -27058,7 +27058,7 @@
           <a:srgbClr val="000000"/>
         </a:buClr>
         <a:buFont typeface="Arial"/>
-        <a:defRPr b="0" i="0" sz="1400" u="none" cap="none" strike="noStrike">
+        <a:defRPr b="0" i="0" spc="0" sz="1400" u="none" cap="none" strike="noStrike">
           <a:solidFill>
             <a:srgbClr val="000000"/>
           </a:solidFill>
@@ -27082,7 +27082,7 @@
           <a:srgbClr val="000000"/>
         </a:buClr>
         <a:buFont typeface="Arial"/>
-        <a:defRPr b="0" i="0" sz="1400" u="none" cap="none" strike="noStrike">
+        <a:defRPr b="0" i="0" spc="0" sz="1400" u="none" cap="none" strike="noStrike">
           <a:solidFill>
             <a:srgbClr val="000000"/>
           </a:solidFill>
@@ -27106,7 +27106,7 @@
           <a:srgbClr val="000000"/>
         </a:buClr>
         <a:buFont typeface="Arial"/>
-        <a:defRPr b="0" i="0" sz="1400" u="none" cap="none" strike="noStrike">
+        <a:defRPr b="0" i="0" spc="0" sz="1400" u="none" cap="none" strike="noStrike">
           <a:solidFill>
             <a:srgbClr val="000000"/>
           </a:solidFill>
@@ -27130,7 +27130,7 @@
           <a:srgbClr val="000000"/>
         </a:buClr>
         <a:buFont typeface="Arial"/>
-        <a:defRPr b="0" i="0" sz="1400" u="none" cap="none" strike="noStrike">
+        <a:defRPr b="0" i="0" spc="0" sz="1400" u="none" cap="none" strike="noStrike">
           <a:solidFill>
             <a:srgbClr val="000000"/>
           </a:solidFill>
@@ -27154,7 +27154,7 @@
           <a:srgbClr val="000000"/>
         </a:buClr>
         <a:buFont typeface="Arial"/>
-        <a:defRPr b="0" i="0" sz="1400" u="none" cap="none" strike="noStrike">
+        <a:defRPr b="0" i="0" spc="0" sz="1400" u="none" cap="none" strike="noStrike">
           <a:solidFill>
             <a:srgbClr val="000000"/>
           </a:solidFill>
@@ -27219,7 +27219,7 @@
             <a:normAutofit/>
           </a:bodyPr>
           <a:lstStyle>
-            <a:lvl1pPr lvl="0" marR="0" rtl="0" algn="l">
+            <a:lvl1pPr lvl="0" marR="0" algn="l">
               <a:lnSpc>
                 <a:spcPct val="100000"/>
               </a:lnSpc>
@@ -27245,7 +27245,7 @@
                 <a:sym typeface="Arial"/>
               </a:defRPr>
             </a:lvl1pPr>
-            <a:lvl2pPr lvl="1" marR="0" rtl="0" algn="l">
+            <a:lvl2pPr lvl="1" marR="0" algn="l">
               <a:lnSpc>
                 <a:spcPct val="100000"/>
               </a:lnSpc>
@@ -27271,7 +27271,7 @@
                 <a:sym typeface="Arial"/>
               </a:defRPr>
             </a:lvl2pPr>
-            <a:lvl3pPr lvl="2" marR="0" rtl="0" algn="l">
+            <a:lvl3pPr lvl="2" marR="0" algn="l">
               <a:lnSpc>
                 <a:spcPct val="100000"/>
               </a:lnSpc>
@@ -27297,7 +27297,7 @@
                 <a:sym typeface="Arial"/>
               </a:defRPr>
             </a:lvl3pPr>
-            <a:lvl4pPr lvl="3" marR="0" rtl="0" algn="l">
+            <a:lvl4pPr lvl="3" marR="0" algn="l">
               <a:lnSpc>
                 <a:spcPct val="100000"/>
               </a:lnSpc>
@@ -27323,7 +27323,7 @@
                 <a:sym typeface="Arial"/>
               </a:defRPr>
             </a:lvl4pPr>
-            <a:lvl5pPr lvl="4" marR="0" rtl="0" algn="l">
+            <a:lvl5pPr lvl="4" marR="0" algn="l">
               <a:lnSpc>
                 <a:spcPct val="100000"/>
               </a:lnSpc>
@@ -27349,7 +27349,7 @@
                 <a:sym typeface="Arial"/>
               </a:defRPr>
             </a:lvl5pPr>
-            <a:lvl6pPr lvl="5" marR="0" rtl="0" algn="l">
+            <a:lvl6pPr lvl="5" marR="0" algn="l">
               <a:lnSpc>
                 <a:spcPct val="100000"/>
               </a:lnSpc>
@@ -27375,7 +27375,7 @@
                 <a:sym typeface="Arial"/>
               </a:defRPr>
             </a:lvl6pPr>
-            <a:lvl7pPr lvl="6" marR="0" rtl="0" algn="l">
+            <a:lvl7pPr lvl="6" marR="0" algn="l">
               <a:lnSpc>
                 <a:spcPct val="100000"/>
               </a:lnSpc>
@@ -27401,7 +27401,7 @@
                 <a:sym typeface="Arial"/>
               </a:defRPr>
             </a:lvl7pPr>
-            <a:lvl8pPr lvl="7" marR="0" rtl="0" algn="l">
+            <a:lvl8pPr lvl="7" marR="0" algn="l">
               <a:lnSpc>
                 <a:spcPct val="100000"/>
               </a:lnSpc>
@@ -27427,7 +27427,7 @@
                 <a:sym typeface="Arial"/>
               </a:defRPr>
             </a:lvl8pPr>
-            <a:lvl9pPr lvl="8" marR="0" rtl="0" algn="l">
+            <a:lvl9pPr lvl="8" marR="0" algn="l">
               <a:lnSpc>
                 <a:spcPct val="100000"/>
               </a:lnSpc>
@@ -27483,7 +27483,7 @@
             <a:normAutofit/>
           </a:bodyPr>
           <a:lstStyle>
-            <a:lvl1pPr indent="-342900" lvl="0" marL="457200" marR="0" rtl="0" algn="l">
+            <a:lvl1pPr indent="-342900" lvl="0" marL="457200" marR="0" algn="l">
               <a:lnSpc>
                 <a:spcPct val="115000"/>
               </a:lnSpc>
@@ -27509,7 +27509,7 @@
                 <a:sym typeface="Arial"/>
               </a:defRPr>
             </a:lvl1pPr>
-            <a:lvl2pPr indent="-317500" lvl="1" marL="914400" marR="0" rtl="0" algn="l">
+            <a:lvl2pPr indent="-317500" lvl="1" marL="914400" marR="0" algn="l">
               <a:lnSpc>
                 <a:spcPct val="115000"/>
               </a:lnSpc>
@@ -27535,7 +27535,7 @@
                 <a:sym typeface="Arial"/>
               </a:defRPr>
             </a:lvl2pPr>
-            <a:lvl3pPr indent="-317500" lvl="2" marL="1371600" marR="0" rtl="0" algn="l">
+            <a:lvl3pPr indent="-317500" lvl="2" marL="1371600" marR="0" algn="l">
               <a:lnSpc>
                 <a:spcPct val="115000"/>
               </a:lnSpc>
@@ -27561,7 +27561,7 @@
                 <a:sym typeface="Arial"/>
               </a:defRPr>
             </a:lvl3pPr>
-            <a:lvl4pPr indent="-317500" lvl="3" marL="1828800" marR="0" rtl="0" algn="l">
+            <a:lvl4pPr indent="-317500" lvl="3" marL="1828800" marR="0" algn="l">
               <a:lnSpc>
                 <a:spcPct val="115000"/>
               </a:lnSpc>
@@ -27587,7 +27587,7 @@
                 <a:sym typeface="Arial"/>
               </a:defRPr>
             </a:lvl4pPr>
-            <a:lvl5pPr indent="-317500" lvl="4" marL="2286000" marR="0" rtl="0" algn="l">
+            <a:lvl5pPr indent="-317500" lvl="4" marL="2286000" marR="0" algn="l">
               <a:lnSpc>
                 <a:spcPct val="115000"/>
               </a:lnSpc>
@@ -27613,7 +27613,7 @@
                 <a:sym typeface="Arial"/>
               </a:defRPr>
             </a:lvl5pPr>
-            <a:lvl6pPr indent="-317500" lvl="5" marL="2743200" marR="0" rtl="0" algn="l">
+            <a:lvl6pPr indent="-317500" lvl="5" marL="2743200" marR="0" algn="l">
               <a:lnSpc>
                 <a:spcPct val="115000"/>
               </a:lnSpc>
@@ -27639,7 +27639,7 @@
                 <a:sym typeface="Arial"/>
               </a:defRPr>
             </a:lvl6pPr>
-            <a:lvl7pPr indent="-317500" lvl="6" marL="3200400" marR="0" rtl="0" algn="l">
+            <a:lvl7pPr indent="-317500" lvl="6" marL="3200400" marR="0" algn="l">
               <a:lnSpc>
                 <a:spcPct val="115000"/>
               </a:lnSpc>
@@ -27665,7 +27665,7 @@
                 <a:sym typeface="Arial"/>
               </a:defRPr>
             </a:lvl7pPr>
-            <a:lvl8pPr indent="-317500" lvl="7" marL="3657600" marR="0" rtl="0" algn="l">
+            <a:lvl8pPr indent="-317500" lvl="7" marL="3657600" marR="0" algn="l">
               <a:lnSpc>
                 <a:spcPct val="115000"/>
               </a:lnSpc>
@@ -27691,7 +27691,7 @@
                 <a:sym typeface="Arial"/>
               </a:defRPr>
             </a:lvl8pPr>
-            <a:lvl9pPr indent="-317500" lvl="8" marL="4114800" marR="0" rtl="0" algn="l">
+            <a:lvl9pPr indent="-317500" lvl="8" marL="4114800" marR="0" algn="l">
               <a:lnSpc>
                 <a:spcPct val="115000"/>
               </a:lnSpc>
@@ -27747,7 +27747,7 @@
             <a:normAutofit/>
           </a:bodyPr>
           <a:lstStyle>
-            <a:lvl1pPr indent="0" lvl="0" marL="0" marR="0" rtl="0" algn="r">
+            <a:lvl1pPr indent="0" lvl="0" marL="0" marR="0" algn="r">
               <a:lnSpc>
                 <a:spcPct val="100000"/>
               </a:lnSpc>
@@ -27773,7 +27773,7 @@
                 <a:sym typeface="Arial"/>
               </a:defRPr>
             </a:lvl1pPr>
-            <a:lvl2pPr indent="0" lvl="1" marL="0" marR="0" rtl="0" algn="r">
+            <a:lvl2pPr indent="0" lvl="1" marL="0" marR="0" algn="r">
               <a:lnSpc>
                 <a:spcPct val="100000"/>
               </a:lnSpc>
@@ -27799,7 +27799,7 @@
                 <a:sym typeface="Arial"/>
               </a:defRPr>
             </a:lvl2pPr>
-            <a:lvl3pPr indent="0" lvl="2" marL="0" marR="0" rtl="0" algn="r">
+            <a:lvl3pPr indent="0" lvl="2" marL="0" marR="0" algn="r">
               <a:lnSpc>
                 <a:spcPct val="100000"/>
               </a:lnSpc>
@@ -27825,7 +27825,7 @@
                 <a:sym typeface="Arial"/>
               </a:defRPr>
             </a:lvl3pPr>
-            <a:lvl4pPr indent="0" lvl="3" marL="0" marR="0" rtl="0" algn="r">
+            <a:lvl4pPr indent="0" lvl="3" marL="0" marR="0" algn="r">
               <a:lnSpc>
                 <a:spcPct val="100000"/>
               </a:lnSpc>
@@ -27851,7 +27851,7 @@
                 <a:sym typeface="Arial"/>
               </a:defRPr>
             </a:lvl4pPr>
-            <a:lvl5pPr indent="0" lvl="4" marL="0" marR="0" rtl="0" algn="r">
+            <a:lvl5pPr indent="0" lvl="4" marL="0" marR="0" algn="r">
               <a:lnSpc>
                 <a:spcPct val="100000"/>
               </a:lnSpc>
@@ -27877,7 +27877,7 @@
                 <a:sym typeface="Arial"/>
               </a:defRPr>
             </a:lvl5pPr>
-            <a:lvl6pPr indent="0" lvl="5" marL="0" marR="0" rtl="0" algn="r">
+            <a:lvl6pPr indent="0" lvl="5" marL="0" marR="0" algn="r">
               <a:lnSpc>
                 <a:spcPct val="100000"/>
               </a:lnSpc>
@@ -27903,7 +27903,7 @@
                 <a:sym typeface="Arial"/>
               </a:defRPr>
             </a:lvl6pPr>
-            <a:lvl7pPr indent="0" lvl="6" marL="0" marR="0" rtl="0" algn="r">
+            <a:lvl7pPr indent="0" lvl="6" marL="0" marR="0" algn="r">
               <a:lnSpc>
                 <a:spcPct val="100000"/>
               </a:lnSpc>
@@ -27929,7 +27929,7 @@
                 <a:sym typeface="Arial"/>
               </a:defRPr>
             </a:lvl7pPr>
-            <a:lvl8pPr indent="0" lvl="7" marL="0" marR="0" rtl="0" algn="r">
+            <a:lvl8pPr indent="0" lvl="7" marL="0" marR="0" algn="r">
               <a:lnSpc>
                 <a:spcPct val="100000"/>
               </a:lnSpc>
@@ -27955,7 +27955,7 @@
                 <a:sym typeface="Arial"/>
               </a:defRPr>
             </a:lvl8pPr>
-            <a:lvl9pPr indent="0" lvl="8" marL="0" marR="0" rtl="0" algn="r">
+            <a:lvl9pPr indent="0" lvl="8" marL="0" marR="0" algn="r">
               <a:lnSpc>
                 <a:spcPct val="100000"/>
               </a:lnSpc>
@@ -28044,7 +28044,7 @@
           <a:srgbClr val="000000"/>
         </a:buClr>
         <a:buFont typeface="Arial"/>
-        <a:defRPr b="0" i="0" sz="1400" u="none" cap="none" strike="noStrike">
+        <a:defRPr b="0" i="0" spc="0" sz="1400" u="none" cap="none" strike="noStrike">
           <a:solidFill>
             <a:srgbClr val="000000"/>
           </a:solidFill>
@@ -28068,7 +28068,7 @@
           <a:srgbClr val="000000"/>
         </a:buClr>
         <a:buFont typeface="Arial"/>
-        <a:defRPr b="0" i="0" sz="1400" u="none" cap="none" strike="noStrike">
+        <a:defRPr b="0" i="0" spc="0" sz="1400" u="none" cap="none" strike="noStrike">
           <a:solidFill>
             <a:srgbClr val="000000"/>
           </a:solidFill>
@@ -28092,7 +28092,7 @@
           <a:srgbClr val="000000"/>
         </a:buClr>
         <a:buFont typeface="Arial"/>
-        <a:defRPr b="0" i="0" sz="1400" u="none" cap="none" strike="noStrike">
+        <a:defRPr b="0" i="0" spc="0" sz="1400" u="none" cap="none" strike="noStrike">
           <a:solidFill>
             <a:srgbClr val="000000"/>
           </a:solidFill>
@@ -28116,7 +28116,7 @@
           <a:srgbClr val="000000"/>
         </a:buClr>
         <a:buFont typeface="Arial"/>
-        <a:defRPr b="0" i="0" sz="1400" u="none" cap="none" strike="noStrike">
+        <a:defRPr b="0" i="0" spc="0" sz="1400" u="none" cap="none" strike="noStrike">
           <a:solidFill>
             <a:srgbClr val="000000"/>
           </a:solidFill>
@@ -28140,7 +28140,7 @@
           <a:srgbClr val="000000"/>
         </a:buClr>
         <a:buFont typeface="Arial"/>
-        <a:defRPr b="0" i="0" sz="1400" u="none" cap="none" strike="noStrike">
+        <a:defRPr b="0" i="0" spc="0" sz="1400" u="none" cap="none" strike="noStrike">
           <a:solidFill>
             <a:srgbClr val="000000"/>
           </a:solidFill>
@@ -28164,7 +28164,7 @@
           <a:srgbClr val="000000"/>
         </a:buClr>
         <a:buFont typeface="Arial"/>
-        <a:defRPr b="0" i="0" sz="1400" u="none" cap="none" strike="noStrike">
+        <a:defRPr b="0" i="0" spc="0" sz="1400" u="none" cap="none" strike="noStrike">
           <a:solidFill>
             <a:srgbClr val="000000"/>
           </a:solidFill>
@@ -28188,7 +28188,7 @@
           <a:srgbClr val="000000"/>
         </a:buClr>
         <a:buFont typeface="Arial"/>
-        <a:defRPr b="0" i="0" sz="1400" u="none" cap="none" strike="noStrike">
+        <a:defRPr b="0" i="0" spc="0" sz="1400" u="none" cap="none" strike="noStrike">
           <a:solidFill>
             <a:srgbClr val="000000"/>
           </a:solidFill>
@@ -28212,7 +28212,7 @@
           <a:srgbClr val="000000"/>
         </a:buClr>
         <a:buFont typeface="Arial"/>
-        <a:defRPr b="0" i="0" sz="1400" u="none" cap="none" strike="noStrike">
+        <a:defRPr b="0" i="0" spc="0" sz="1400" u="none" cap="none" strike="noStrike">
           <a:solidFill>
             <a:srgbClr val="000000"/>
           </a:solidFill>
@@ -28236,7 +28236,7 @@
           <a:srgbClr val="000000"/>
         </a:buClr>
         <a:buFont typeface="Arial"/>
-        <a:defRPr b="0" i="0" sz="1400" u="none" cap="none" strike="noStrike">
+        <a:defRPr b="0" i="0" spc="0" sz="1400" u="none" cap="none" strike="noStrike">
           <a:solidFill>
             <a:srgbClr val="000000"/>
           </a:solidFill>
@@ -28273,7 +28273,7 @@
           <a:srgbClr val="000000"/>
         </a:buClr>
         <a:buFont typeface="Arial"/>
-        <a:defRPr b="0" i="0" sz="1400" u="none" cap="none" strike="noStrike">
+        <a:defRPr b="0" i="0" spc="0" sz="1400" u="none" cap="none" strike="noStrike">
           <a:solidFill>
             <a:srgbClr val="000000"/>
           </a:solidFill>
@@ -28297,7 +28297,7 @@
           <a:srgbClr val="000000"/>
         </a:buClr>
         <a:buFont typeface="Arial"/>
-        <a:defRPr b="0" i="0" sz="1400" u="none" cap="none" strike="noStrike">
+        <a:defRPr b="0" i="0" spc="0" sz="1400" u="none" cap="none" strike="noStrike">
           <a:solidFill>
             <a:srgbClr val="000000"/>
           </a:solidFill>
@@ -28321,7 +28321,7 @@
           <a:srgbClr val="000000"/>
         </a:buClr>
         <a:buFont typeface="Arial"/>
-        <a:defRPr b="0" i="0" sz="1400" u="none" cap="none" strike="noStrike">
+        <a:defRPr b="0" i="0" spc="0" sz="1400" u="none" cap="none" strike="noStrike">
           <a:solidFill>
             <a:srgbClr val="000000"/>
           </a:solidFill>
@@ -28345,7 +28345,7 @@
           <a:srgbClr val="000000"/>
         </a:buClr>
         <a:buFont typeface="Arial"/>
-        <a:defRPr b="0" i="0" sz="1400" u="none" cap="none" strike="noStrike">
+        <a:defRPr b="0" i="0" spc="0" sz="1400" u="none" cap="none" strike="noStrike">
           <a:solidFill>
             <a:srgbClr val="000000"/>
           </a:solidFill>
@@ -28369,7 +28369,7 @@
           <a:srgbClr val="000000"/>
         </a:buClr>
         <a:buFont typeface="Arial"/>
-        <a:defRPr b="0" i="0" sz="1400" u="none" cap="none" strike="noStrike">
+        <a:defRPr b="0" i="0" spc="0" sz="1400" u="none" cap="none" strike="noStrike">
           <a:solidFill>
             <a:srgbClr val="000000"/>
           </a:solidFill>
@@ -28393,7 +28393,7 @@
           <a:srgbClr val="000000"/>
         </a:buClr>
         <a:buFont typeface="Arial"/>
-        <a:defRPr b="0" i="0" sz="1400" u="none" cap="none" strike="noStrike">
+        <a:defRPr b="0" i="0" spc="0" sz="1400" u="none" cap="none" strike="noStrike">
           <a:solidFill>
             <a:srgbClr val="000000"/>
           </a:solidFill>
@@ -28417,7 +28417,7 @@
           <a:srgbClr val="000000"/>
         </a:buClr>
         <a:buFont typeface="Arial"/>
-        <a:defRPr b="0" i="0" sz="1400" u="none" cap="none" strike="noStrike">
+        <a:defRPr b="0" i="0" spc="0" sz="1400" u="none" cap="none" strike="noStrike">
           <a:solidFill>
             <a:srgbClr val="000000"/>
           </a:solidFill>
@@ -28441,7 +28441,7 @@
           <a:srgbClr val="000000"/>
         </a:buClr>
         <a:buFont typeface="Arial"/>
-        <a:defRPr b="0" i="0" sz="1400" u="none" cap="none" strike="noStrike">
+        <a:defRPr b="0" i="0" spc="0" sz="1400" u="none" cap="none" strike="noStrike">
           <a:solidFill>
             <a:srgbClr val="000000"/>
           </a:solidFill>
@@ -28465,7 +28465,7 @@
           <a:srgbClr val="000000"/>
         </a:buClr>
         <a:buFont typeface="Arial"/>
-        <a:defRPr b="0" i="0" sz="1400" u="none" cap="none" strike="noStrike">
+        <a:defRPr b="0" i="0" spc="0" sz="1400" u="none" cap="none" strike="noStrike">
           <a:solidFill>
             <a:srgbClr val="000000"/>
           </a:solidFill>
@@ -28502,7 +28502,7 @@
           <a:srgbClr val="000000"/>
         </a:buClr>
         <a:buFont typeface="Arial"/>
-        <a:defRPr b="0" i="0" sz="1400" u="none" cap="none" strike="noStrike">
+        <a:defRPr b="0" i="0" spc="0" sz="1400" u="none" cap="none" strike="noStrike">
           <a:solidFill>
             <a:srgbClr val="000000"/>
           </a:solidFill>
@@ -28526,7 +28526,7 @@
           <a:srgbClr val="000000"/>
         </a:buClr>
         <a:buFont typeface="Arial"/>
-        <a:defRPr b="0" i="0" sz="1400" u="none" cap="none" strike="noStrike">
+        <a:defRPr b="0" i="0" spc="0" sz="1400" u="none" cap="none" strike="noStrike">
           <a:solidFill>
             <a:srgbClr val="000000"/>
           </a:solidFill>
@@ -28550,7 +28550,7 @@
           <a:srgbClr val="000000"/>
         </a:buClr>
         <a:buFont typeface="Arial"/>
-        <a:defRPr b="0" i="0" sz="1400" u="none" cap="none" strike="noStrike">
+        <a:defRPr b="0" i="0" spc="0" sz="1400" u="none" cap="none" strike="noStrike">
           <a:solidFill>
             <a:srgbClr val="000000"/>
           </a:solidFill>
@@ -28574,7 +28574,7 @@
           <a:srgbClr val="000000"/>
         </a:buClr>
         <a:buFont typeface="Arial"/>
-        <a:defRPr b="0" i="0" sz="1400" u="none" cap="none" strike="noStrike">
+        <a:defRPr b="0" i="0" spc="0" sz="1400" u="none" cap="none" strike="noStrike">
           <a:solidFill>
             <a:srgbClr val="000000"/>
           </a:solidFill>
@@ -28598,7 +28598,7 @@
           <a:srgbClr val="000000"/>
         </a:buClr>
         <a:buFont typeface="Arial"/>
-        <a:defRPr b="0" i="0" sz="1400" u="none" cap="none" strike="noStrike">
+        <a:defRPr b="0" i="0" spc="0" sz="1400" u="none" cap="none" strike="noStrike">
           <a:solidFill>
             <a:srgbClr val="000000"/>
           </a:solidFill>
@@ -28622,7 +28622,7 @@
           <a:srgbClr val="000000"/>
         </a:buClr>
         <a:buFont typeface="Arial"/>
-        <a:defRPr b="0" i="0" sz="1400" u="none" cap="none" strike="noStrike">
+        <a:defRPr b="0" i="0" spc="0" sz="1400" u="none" cap="none" strike="noStrike">
           <a:solidFill>
             <a:srgbClr val="000000"/>
           </a:solidFill>
@@ -28646,7 +28646,7 @@
           <a:srgbClr val="000000"/>
         </a:buClr>
         <a:buFont typeface="Arial"/>
-        <a:defRPr b="0" i="0" sz="1400" u="none" cap="none" strike="noStrike">
+        <a:defRPr b="0" i="0" spc="0" sz="1400" u="none" cap="none" strike="noStrike">
           <a:solidFill>
             <a:srgbClr val="000000"/>
           </a:solidFill>
@@ -28670,7 +28670,7 @@
           <a:srgbClr val="000000"/>
         </a:buClr>
         <a:buFont typeface="Arial"/>
-        <a:defRPr b="0" i="0" sz="1400" u="none" cap="none" strike="noStrike">
+        <a:defRPr b="0" i="0" spc="0" sz="1400" u="none" cap="none" strike="noStrike">
           <a:solidFill>
             <a:srgbClr val="000000"/>
           </a:solidFill>
@@ -28694,7 +28694,7 @@
           <a:srgbClr val="000000"/>
         </a:buClr>
         <a:buFont typeface="Arial"/>
-        <a:defRPr b="0" i="0" sz="1400" u="none" cap="none" strike="noStrike">
+        <a:defRPr b="0" i="0" spc="0" sz="1400" u="none" cap="none" strike="noStrike">
           <a:solidFill>
             <a:srgbClr val="000000"/>
           </a:solidFill>
@@ -36813,7 +36813,7 @@
             <a:tbl>
               <a:tblPr>
                 <a:noFill/>
-                <a:tableStyleId>{7105D537-239D-4BBD-A6FD-BB8609C5E33B}</a:tableStyleId>
+                <a:tableStyleId>{3490F3D7-4271-4291-8D71-B0AB4515BED5}</a:tableStyleId>
               </a:tblPr>
               <a:tblGrid>
                 <a:gridCol w="1188725"/>
@@ -38390,7 +38390,7 @@
           <a:effectLst>
             <a:outerShdw blurRad="50800" rotWithShape="0" algn="bl" dir="8100000" dist="25400">
               <a:srgbClr val="000000">
-                <a:alpha val="7843"/>
+                <a:alpha val="7840"/>
               </a:srgbClr>
             </a:outerShdw>
           </a:effectLst>
@@ -38647,7 +38647,7 @@
           <a:effectLst>
             <a:outerShdw blurRad="50800" rotWithShape="0" algn="bl" dir="8100000" dist="25400">
               <a:srgbClr val="000000">
-                <a:alpha val="7843"/>
+                <a:alpha val="7840"/>
               </a:srgbClr>
             </a:outerShdw>
           </a:effectLst>
@@ -38904,7 +38904,7 @@
           <a:effectLst>
             <a:outerShdw blurRad="50800" rotWithShape="0" algn="bl" dir="8100000" dist="25400">
               <a:srgbClr val="000000">
-                <a:alpha val="7843"/>
+                <a:alpha val="7840"/>
               </a:srgbClr>
             </a:outerShdw>
           </a:effectLst>
@@ -39161,7 +39161,7 @@
           <a:effectLst>
             <a:outerShdw blurRad="50800" rotWithShape="0" algn="bl" dir="8100000" dist="25400">
               <a:srgbClr val="000000">
-                <a:alpha val="7843"/>
+                <a:alpha val="7840"/>
               </a:srgbClr>
             </a:outerShdw>
           </a:effectLst>
@@ -39418,7 +39418,7 @@
           <a:effectLst>
             <a:outerShdw blurRad="50800" rotWithShape="0" algn="bl" dir="8100000" dist="25400">
               <a:srgbClr val="000000">
-                <a:alpha val="7843"/>
+                <a:alpha val="7840"/>
               </a:srgbClr>
             </a:outerShdw>
           </a:effectLst>
@@ -39675,7 +39675,7 @@
           <a:effectLst>
             <a:outerShdw blurRad="50800" rotWithShape="0" algn="bl" dir="8100000" dist="25400">
               <a:srgbClr val="000000">
-                <a:alpha val="7843"/>
+                <a:alpha val="7840"/>
               </a:srgbClr>
             </a:outerShdw>
           </a:effectLst>
@@ -54734,9 +54734,9 @@
 </file>
 
 <file path=ppt/theme/theme1.xml><?xml version="1.0" encoding="utf-8"?>
-<a:theme xmlns:a="http://schemas.openxmlformats.org/drawingml/2006/main" xmlns:r="http://schemas.openxmlformats.org/officeDocument/2006/relationships">
+<a:theme xmlns:a="http://schemas.openxmlformats.org/drawingml/2006/main" xmlns:r="http://schemas.openxmlformats.org/officeDocument/2006/relationships" name="Simple Light">
   <a:themeElements>
-    <a:clrScheme name="Default">
+    <a:clrScheme name="Simple Light">
       <a:dk1>
         <a:srgbClr val="000000"/>
       </a:dk1>
@@ -54744,34 +54744,34 @@
         <a:srgbClr val="FFFFFF"/>
       </a:lt1>
       <a:dk2>
-        <a:srgbClr val="158158"/>
+        <a:srgbClr val="595959"/>
       </a:dk2>
       <a:lt2>
-        <a:srgbClr val="F3F3F3"/>
+        <a:srgbClr val="EEEEEE"/>
       </a:lt2>
       <a:accent1>
-        <a:srgbClr val="058DC7"/>
+        <a:srgbClr val="4285F4"/>
       </a:accent1>
       <a:accent2>
-        <a:srgbClr val="50B432"/>
+        <a:srgbClr val="212121"/>
       </a:accent2>
       <a:accent3>
-        <a:srgbClr val="ED561B"/>
+        <a:srgbClr val="78909C"/>
       </a:accent3>
       <a:accent4>
-        <a:srgbClr val="EDEF00"/>
+        <a:srgbClr val="FFAB40"/>
       </a:accent4>
       <a:accent5>
-        <a:srgbClr val="24CBE5"/>
+        <a:srgbClr val="0097A7"/>
       </a:accent5>
       <a:accent6>
-        <a:srgbClr val="64E572"/>
+        <a:srgbClr val="EEFF41"/>
       </a:accent6>
       <a:hlink>
-        <a:srgbClr val="2200CC"/>
+        <a:srgbClr val="0097A7"/>
       </a:hlink>
       <a:folHlink>
-        <a:srgbClr val="551A8B"/>
+        <a:srgbClr val="0097A7"/>
       </a:folHlink>
     </a:clrScheme>
     <a:fontScheme name="Office">
@@ -55013,9 +55013,9 @@
 </file>
 
 <file path=ppt/theme/theme2.xml><?xml version="1.0" encoding="utf-8"?>
-<a:theme xmlns:a="http://schemas.openxmlformats.org/drawingml/2006/main" xmlns:r="http://schemas.openxmlformats.org/officeDocument/2006/relationships" name="Office Theme">
+<a:theme xmlns:a="http://schemas.openxmlformats.org/drawingml/2006/main" xmlns:r="http://schemas.openxmlformats.org/officeDocument/2006/relationships" name="Simple Light">
   <a:themeElements>
-    <a:clrScheme name="Office">
+    <a:clrScheme name="Simple Light">
       <a:dk1>
         <a:srgbClr val="000000"/>
       </a:dk1>
@@ -55023,34 +55023,34 @@
         <a:srgbClr val="FFFFFF"/>
       </a:lt1>
       <a:dk2>
-        <a:srgbClr val="44546A"/>
+        <a:srgbClr val="595959"/>
       </a:dk2>
       <a:lt2>
-        <a:srgbClr val="E7E6E6"/>
+        <a:srgbClr val="EEEEEE"/>
       </a:lt2>
       <a:accent1>
-        <a:srgbClr val="4472C4"/>
+        <a:srgbClr val="4285F4"/>
       </a:accent1>
       <a:accent2>
-        <a:srgbClr val="ED7D31"/>
+        <a:srgbClr val="212121"/>
       </a:accent2>
       <a:accent3>
-        <a:srgbClr val="A5A5A5"/>
+        <a:srgbClr val="78909C"/>
       </a:accent3>
       <a:accent4>
-        <a:srgbClr val="FFC000"/>
+        <a:srgbClr val="FFAB40"/>
       </a:accent4>
       <a:accent5>
-        <a:srgbClr val="5B9BD5"/>
+        <a:srgbClr val="0097A7"/>
       </a:accent5>
       <a:accent6>
-        <a:srgbClr val="70AD47"/>
+        <a:srgbClr val="EEFF41"/>
       </a:accent6>
       <a:hlink>
-        <a:srgbClr val="0563C1"/>
+        <a:srgbClr val="0097A7"/>
       </a:hlink>
       <a:folHlink>
-        <a:srgbClr val="954F72"/>
+        <a:srgbClr val="0097A7"/>
       </a:folHlink>
     </a:clrScheme>
     <a:fontScheme name="Office">
@@ -55571,9 +55571,9 @@
 </file>
 
 <file path=ppt/theme/theme4.xml><?xml version="1.0" encoding="utf-8"?>
-<a:theme xmlns:a="http://schemas.openxmlformats.org/drawingml/2006/main" xmlns:r="http://schemas.openxmlformats.org/officeDocument/2006/relationships" name="Simple Light">
+<a:theme xmlns:a="http://schemas.openxmlformats.org/drawingml/2006/main" xmlns:r="http://schemas.openxmlformats.org/officeDocument/2006/relationships">
   <a:themeElements>
-    <a:clrScheme name="Simple Light">
+    <a:clrScheme name="Default">
       <a:dk1>
         <a:srgbClr val="000000"/>
       </a:dk1>
@@ -55581,34 +55581,34 @@
         <a:srgbClr val="FFFFFF"/>
       </a:lt1>
       <a:dk2>
-        <a:srgbClr val="595959"/>
+        <a:srgbClr val="158158"/>
       </a:dk2>
       <a:lt2>
-        <a:srgbClr val="EEEEEE"/>
+        <a:srgbClr val="F3F3F3"/>
       </a:lt2>
       <a:accent1>
-        <a:srgbClr val="4285F4"/>
+        <a:srgbClr val="058DC7"/>
       </a:accent1>
       <a:accent2>
-        <a:srgbClr val="212121"/>
+        <a:srgbClr val="50B432"/>
       </a:accent2>
       <a:accent3>
-        <a:srgbClr val="78909C"/>
+        <a:srgbClr val="ED561B"/>
       </a:accent3>
       <a:accent4>
-        <a:srgbClr val="FFAB40"/>
+        <a:srgbClr val="EDEF00"/>
       </a:accent4>
       <a:accent5>
-        <a:srgbClr val="0097A7"/>
+        <a:srgbClr val="24CBE5"/>
       </a:accent5>
       <a:accent6>
-        <a:srgbClr val="EEFF41"/>
+        <a:srgbClr val="64E572"/>
       </a:accent6>
       <a:hlink>
-        <a:srgbClr val="0097A7"/>
+        <a:srgbClr val="2200CC"/>
       </a:hlink>
       <a:folHlink>
-        <a:srgbClr val="0097A7"/>
+        <a:srgbClr val="551A8B"/>
       </a:folHlink>
     </a:clrScheme>
     <a:fontScheme name="Office">
@@ -55850,9 +55850,9 @@
 </file>
 
 <file path=ppt/theme/theme5.xml><?xml version="1.0" encoding="utf-8"?>
-<a:theme xmlns:a="http://schemas.openxmlformats.org/drawingml/2006/main" xmlns:r="http://schemas.openxmlformats.org/officeDocument/2006/relationships" name="Simple Light">
+<a:theme xmlns:a="http://schemas.openxmlformats.org/drawingml/2006/main" xmlns:r="http://schemas.openxmlformats.org/officeDocument/2006/relationships" name="Office Theme">
   <a:themeElements>
-    <a:clrScheme name="Simple Light">
+    <a:clrScheme name="Office">
       <a:dk1>
         <a:srgbClr val="000000"/>
       </a:dk1>
@@ -55860,34 +55860,34 @@
         <a:srgbClr val="FFFFFF"/>
       </a:lt1>
       <a:dk2>
-        <a:srgbClr val="595959"/>
+        <a:srgbClr val="44546A"/>
       </a:dk2>
       <a:lt2>
-        <a:srgbClr val="EEEEEE"/>
+        <a:srgbClr val="E7E6E6"/>
       </a:lt2>
       <a:accent1>
-        <a:srgbClr val="4285F4"/>
+        <a:srgbClr val="4472C4"/>
       </a:accent1>
       <a:accent2>
-        <a:srgbClr val="212121"/>
+        <a:srgbClr val="ED7D31"/>
       </a:accent2>
       <a:accent3>
-        <a:srgbClr val="78909C"/>
+        <a:srgbClr val="A5A5A5"/>
       </a:accent3>
       <a:accent4>
-        <a:srgbClr val="FFAB40"/>
+        <a:srgbClr val="FFC000"/>
       </a:accent4>
       <a:accent5>
-        <a:srgbClr val="0097A7"/>
+        <a:srgbClr val="5B9BD5"/>
       </a:accent5>
       <a:accent6>
-        <a:srgbClr val="EEFF41"/>
+        <a:srgbClr val="70AD47"/>
       </a:accent6>
       <a:hlink>
-        <a:srgbClr val="0097A7"/>
+        <a:srgbClr val="0563C1"/>
       </a:hlink>
       <a:folHlink>
-        <a:srgbClr val="0097A7"/>
+        <a:srgbClr val="954F72"/>
       </a:folHlink>
     </a:clrScheme>
     <a:fontScheme name="Office">

</xml_diff>